<commit_message>
Add Smollan logo to analysis slides and fix slide 3 spacing
Place the content logo on slides 2–4, add space under section titles, and replace the squashed price-ladder bars with readable price cards.

Co-authored-by: Bongumusa Joseph Hlongwane <Joemusa@users.noreply.github.com>
</commit_message>
<xml_diff>
--- a/output/Unilever_Pasta_Noodles_Jun2026.pptx
+++ b/output/Unilever_Pasta_Noodles_Jun2026.pptx
@@ -3471,7 +3471,7 @@
         <p:spPr>
           <a:xfrm>
             <a:off x="347472" y="164592"/>
-            <a:ext cx="11338560" cy="420624"/>
+            <a:ext cx="9509760" cy="420624"/>
           </a:xfrm>
           <a:prstGeom prst="rect">
             <a:avLst/>
@@ -3486,7 +3486,7 @@
           <a:p>
             <a:pPr algn="l"/>
             <a:r>
-              <a:rPr sz="2600" b="1">
+              <a:rPr sz="2400" b="1">
                 <a:solidFill>
                   <a:srgbClr val="122A4A"/>
                 </a:solidFill>
@@ -3540,9 +3540,33 @@
           </a:p>
         </p:txBody>
       </p:sp>
-      <p:sp>
-        <p:nvSpPr>
-          <p:cNvPr id="7" name="Rectangle 6"/>
+      <p:pic>
+        <p:nvPicPr>
+          <p:cNvPr id="7" name="Picture 6" descr="smollan_logo_content.png"/>
+          <p:cNvPicPr>
+            <a:picLocks noChangeAspect="1"/>
+          </p:cNvPicPr>
+          <p:nvPr/>
+        </p:nvPicPr>
+        <p:blipFill>
+          <a:blip r:embed="rId2"/>
+          <a:stretch>
+            <a:fillRect/>
+          </a:stretch>
+        </p:blipFill>
+        <p:spPr>
+          <a:xfrm>
+            <a:off x="10104120" y="128016"/>
+            <a:ext cx="1783080" cy="384048"/>
+          </a:xfrm>
+          <a:prstGeom prst="rect">
+            <a:avLst/>
+          </a:prstGeom>
+        </p:spPr>
+      </p:pic>
+      <p:sp>
+        <p:nvSpPr>
+          <p:cNvPr id="8" name="Rectangle 7"/>
           <p:cNvSpPr/>
           <p:nvPr/>
         </p:nvSpPr>
@@ -3585,7 +3609,7 @@
       </p:sp>
       <p:sp>
         <p:nvSpPr>
-          <p:cNvPr id="8" name="TextBox 7"/>
+          <p:cNvPr id="9" name="TextBox 8"/>
           <p:cNvSpPr txBox="1"/>
           <p:nvPr/>
         </p:nvSpPr>
@@ -3620,7 +3644,7 @@
       </p:sp>
       <p:sp>
         <p:nvSpPr>
-          <p:cNvPr id="9" name="TextBox 8"/>
+          <p:cNvPr id="10" name="TextBox 9"/>
           <p:cNvSpPr txBox="1"/>
           <p:nvPr/>
         </p:nvSpPr>
@@ -3655,7 +3679,7 @@
       </p:sp>
       <p:sp>
         <p:nvSpPr>
-          <p:cNvPr id="10" name="Rectangle 9"/>
+          <p:cNvPr id="11" name="Rectangle 10"/>
           <p:cNvSpPr/>
           <p:nvPr/>
         </p:nvSpPr>
@@ -3700,7 +3724,7 @@
       </p:sp>
       <p:sp>
         <p:nvSpPr>
-          <p:cNvPr id="11" name="Rectangle 10"/>
+          <p:cNvPr id="12" name="Rectangle 11"/>
           <p:cNvSpPr/>
           <p:nvPr/>
         </p:nvSpPr>
@@ -3743,7 +3767,7 @@
       </p:sp>
       <p:sp>
         <p:nvSpPr>
-          <p:cNvPr id="12" name="TextBox 11"/>
+          <p:cNvPr id="13" name="TextBox 12"/>
           <p:cNvSpPr txBox="1"/>
           <p:nvPr/>
         </p:nvSpPr>
@@ -3778,7 +3802,7 @@
       </p:sp>
       <p:sp>
         <p:nvSpPr>
-          <p:cNvPr id="13" name="TextBox 12"/>
+          <p:cNvPr id="14" name="TextBox 13"/>
           <p:cNvSpPr txBox="1"/>
           <p:nvPr/>
         </p:nvSpPr>
@@ -3813,7 +3837,7 @@
       </p:sp>
       <p:sp>
         <p:nvSpPr>
-          <p:cNvPr id="14" name="TextBox 13"/>
+          <p:cNvPr id="15" name="TextBox 14"/>
           <p:cNvSpPr txBox="1"/>
           <p:nvPr/>
         </p:nvSpPr>
@@ -3848,7 +3872,7 @@
       </p:sp>
       <p:sp>
         <p:nvSpPr>
-          <p:cNvPr id="15" name="Rectangle 14"/>
+          <p:cNvPr id="16" name="Rectangle 15"/>
           <p:cNvSpPr/>
           <p:nvPr/>
         </p:nvSpPr>
@@ -3893,7 +3917,7 @@
       </p:sp>
       <p:sp>
         <p:nvSpPr>
-          <p:cNvPr id="16" name="Rectangle 15"/>
+          <p:cNvPr id="17" name="Rectangle 16"/>
           <p:cNvSpPr/>
           <p:nvPr/>
         </p:nvSpPr>
@@ -3936,7 +3960,7 @@
       </p:sp>
       <p:sp>
         <p:nvSpPr>
-          <p:cNvPr id="17" name="TextBox 16"/>
+          <p:cNvPr id="18" name="TextBox 17"/>
           <p:cNvSpPr txBox="1"/>
           <p:nvPr/>
         </p:nvSpPr>
@@ -3971,7 +3995,7 @@
       </p:sp>
       <p:sp>
         <p:nvSpPr>
-          <p:cNvPr id="18" name="TextBox 17"/>
+          <p:cNvPr id="19" name="TextBox 18"/>
           <p:cNvSpPr txBox="1"/>
           <p:nvPr/>
         </p:nvSpPr>
@@ -4006,7 +4030,7 @@
       </p:sp>
       <p:sp>
         <p:nvSpPr>
-          <p:cNvPr id="19" name="TextBox 18"/>
+          <p:cNvPr id="20" name="TextBox 19"/>
           <p:cNvSpPr txBox="1"/>
           <p:nvPr/>
         </p:nvSpPr>
@@ -4041,7 +4065,7 @@
       </p:sp>
       <p:sp>
         <p:nvSpPr>
-          <p:cNvPr id="20" name="Rectangle 19"/>
+          <p:cNvPr id="21" name="Rectangle 20"/>
           <p:cNvSpPr/>
           <p:nvPr/>
         </p:nvSpPr>
@@ -4086,7 +4110,7 @@
       </p:sp>
       <p:sp>
         <p:nvSpPr>
-          <p:cNvPr id="21" name="Rectangle 20"/>
+          <p:cNvPr id="22" name="Rectangle 21"/>
           <p:cNvSpPr/>
           <p:nvPr/>
         </p:nvSpPr>
@@ -4129,7 +4153,7 @@
       </p:sp>
       <p:sp>
         <p:nvSpPr>
-          <p:cNvPr id="22" name="TextBox 21"/>
+          <p:cNvPr id="23" name="TextBox 22"/>
           <p:cNvSpPr txBox="1"/>
           <p:nvPr/>
         </p:nvSpPr>
@@ -4164,7 +4188,7 @@
       </p:sp>
       <p:sp>
         <p:nvSpPr>
-          <p:cNvPr id="23" name="TextBox 22"/>
+          <p:cNvPr id="24" name="TextBox 23"/>
           <p:cNvSpPr txBox="1"/>
           <p:nvPr/>
         </p:nvSpPr>
@@ -4199,7 +4223,7 @@
       </p:sp>
       <p:sp>
         <p:nvSpPr>
-          <p:cNvPr id="24" name="TextBox 23"/>
+          <p:cNvPr id="25" name="TextBox 24"/>
           <p:cNvSpPr txBox="1"/>
           <p:nvPr/>
         </p:nvSpPr>
@@ -4234,7 +4258,7 @@
       </p:sp>
       <p:sp>
         <p:nvSpPr>
-          <p:cNvPr id="25" name="Rectangle 24"/>
+          <p:cNvPr id="26" name="Rectangle 25"/>
           <p:cNvSpPr/>
           <p:nvPr/>
         </p:nvSpPr>
@@ -4279,7 +4303,7 @@
       </p:sp>
       <p:sp>
         <p:nvSpPr>
-          <p:cNvPr id="26" name="Rectangle 25"/>
+          <p:cNvPr id="27" name="Rectangle 26"/>
           <p:cNvSpPr/>
           <p:nvPr/>
         </p:nvSpPr>
@@ -4322,7 +4346,7 @@
       </p:sp>
       <p:sp>
         <p:nvSpPr>
-          <p:cNvPr id="27" name="TextBox 26"/>
+          <p:cNvPr id="28" name="TextBox 27"/>
           <p:cNvSpPr txBox="1"/>
           <p:nvPr/>
         </p:nvSpPr>
@@ -4357,7 +4381,7 @@
       </p:sp>
       <p:sp>
         <p:nvSpPr>
-          <p:cNvPr id="28" name="TextBox 27"/>
+          <p:cNvPr id="29" name="TextBox 28"/>
           <p:cNvSpPr txBox="1"/>
           <p:nvPr/>
         </p:nvSpPr>
@@ -4392,7 +4416,7 @@
       </p:sp>
       <p:sp>
         <p:nvSpPr>
-          <p:cNvPr id="29" name="TextBox 28"/>
+          <p:cNvPr id="30" name="TextBox 29"/>
           <p:cNvSpPr txBox="1"/>
           <p:nvPr/>
         </p:nvSpPr>
@@ -4427,7 +4451,7 @@
       </p:sp>
       <p:sp>
         <p:nvSpPr>
-          <p:cNvPr id="30" name="TextBox 29"/>
+          <p:cNvPr id="31" name="TextBox 30"/>
           <p:cNvSpPr txBox="1"/>
           <p:nvPr/>
         </p:nvSpPr>
@@ -4462,22 +4486,22 @@
       </p:sp>
       <p:pic>
         <p:nvPicPr>
-          <p:cNvPr id="31" name="Picture 30" descr="data_subcat.png"/>
+          <p:cNvPr id="32" name="Picture 31" descr="data_subcat.png"/>
           <p:cNvPicPr>
             <a:picLocks noChangeAspect="1"/>
           </p:cNvPicPr>
           <p:nvPr/>
         </p:nvPicPr>
         <p:blipFill>
-          <a:blip r:embed="rId2"/>
+          <a:blip r:embed="rId3"/>
           <a:stretch>
             <a:fillRect/>
           </a:stretch>
         </p:blipFill>
         <p:spPr>
           <a:xfrm>
-            <a:off x="256032" y="2231136"/>
-            <a:ext cx="5897880" cy="2926080"/>
+            <a:off x="256032" y="2359152"/>
+            <a:ext cx="5852160" cy="2527069"/>
           </a:xfrm>
           <a:prstGeom prst="rect">
             <a:avLst/>
@@ -4486,7 +4510,7 @@
       </p:pic>
       <p:sp>
         <p:nvSpPr>
-          <p:cNvPr id="32" name="TextBox 31"/>
+          <p:cNvPr id="33" name="TextBox 32"/>
           <p:cNvSpPr txBox="1"/>
           <p:nvPr/>
         </p:nvSpPr>
@@ -4521,14 +4545,14 @@
       </p:sp>
       <p:graphicFrame>
         <p:nvGraphicFramePr>
-          <p:cNvPr id="33" name="Table 32"/>
+          <p:cNvPr id="34" name="Table 33"/>
           <p:cNvGraphicFramePr>
             <a:graphicFrameLocks noGrp="1"/>
           </p:cNvGraphicFramePr>
           <p:nvPr/>
         </p:nvGraphicFramePr>
         <p:xfrm>
-          <a:off x="6309360" y="2267712"/>
+          <a:off x="6309360" y="2359152"/>
           <a:ext cx="5532120" cy="2880360"/>
         </p:xfrm>
         <a:graphic>
@@ -5486,14 +5510,14 @@
       </p:graphicFrame>
       <p:sp>
         <p:nvSpPr>
-          <p:cNvPr id="34" name="TextBox 33"/>
+          <p:cNvPr id="35" name="TextBox 34"/>
           <p:cNvSpPr txBox="1"/>
           <p:nvPr/>
         </p:nvSpPr>
         <p:spPr>
           <a:xfrm>
-            <a:off x="347472" y="5285232"/>
-            <a:ext cx="11475720" cy="1115568"/>
+            <a:off x="347472" y="5074920"/>
+            <a:ext cx="11475720" cy="1325880"/>
           </a:xfrm>
           <a:prstGeom prst="rect">
             <a:avLst/>
@@ -5675,7 +5699,7 @@
         <p:spPr>
           <a:xfrm>
             <a:off x="347472" y="164592"/>
-            <a:ext cx="11338560" cy="420624"/>
+            <a:ext cx="9509760" cy="420624"/>
           </a:xfrm>
           <a:prstGeom prst="rect">
             <a:avLst/>
@@ -5690,7 +5714,7 @@
           <a:p>
             <a:pPr algn="l"/>
             <a:r>
-              <a:rPr sz="2600" b="1">
+              <a:rPr sz="2400" b="1">
                 <a:solidFill>
                   <a:srgbClr val="122A4A"/>
                 </a:solidFill>
@@ -5744,9 +5768,33 @@
           </a:p>
         </p:txBody>
       </p:sp>
-      <p:sp>
-        <p:nvSpPr>
-          <p:cNvPr id="7" name="Rectangle 6"/>
+      <p:pic>
+        <p:nvPicPr>
+          <p:cNvPr id="7" name="Picture 6" descr="smollan_logo_content.png"/>
+          <p:cNvPicPr>
+            <a:picLocks noChangeAspect="1"/>
+          </p:cNvPicPr>
+          <p:nvPr/>
+        </p:nvPicPr>
+        <p:blipFill>
+          <a:blip r:embed="rId2"/>
+          <a:stretch>
+            <a:fillRect/>
+          </a:stretch>
+        </p:blipFill>
+        <p:spPr>
+          <a:xfrm>
+            <a:off x="10104120" y="128016"/>
+            <a:ext cx="1783080" cy="384048"/>
+          </a:xfrm>
+          <a:prstGeom prst="rect">
+            <a:avLst/>
+          </a:prstGeom>
+        </p:spPr>
+      </p:pic>
+      <p:sp>
+        <p:nvSpPr>
+          <p:cNvPr id="8" name="Rectangle 7"/>
           <p:cNvSpPr/>
           <p:nvPr/>
         </p:nvSpPr>
@@ -5789,7 +5837,7 @@
       </p:sp>
       <p:sp>
         <p:nvSpPr>
-          <p:cNvPr id="8" name="TextBox 7"/>
+          <p:cNvPr id="9" name="TextBox 8"/>
           <p:cNvSpPr txBox="1"/>
           <p:nvPr/>
         </p:nvSpPr>
@@ -5824,7 +5872,7 @@
       </p:sp>
       <p:sp>
         <p:nvSpPr>
-          <p:cNvPr id="9" name="TextBox 8"/>
+          <p:cNvPr id="10" name="TextBox 9"/>
           <p:cNvSpPr txBox="1"/>
           <p:nvPr/>
         </p:nvSpPr>
@@ -5859,14 +5907,14 @@
       </p:sp>
       <p:sp>
         <p:nvSpPr>
-          <p:cNvPr id="10" name="Rectangle 9"/>
+          <p:cNvPr id="11" name="Rectangle 10"/>
           <p:cNvSpPr/>
           <p:nvPr/>
         </p:nvSpPr>
         <p:spPr>
           <a:xfrm>
-            <a:off x="347472" y="804672"/>
-            <a:ext cx="2834640" cy="987552"/>
+            <a:off x="347472" y="786384"/>
+            <a:ext cx="2834640" cy="877824"/>
           </a:xfrm>
           <a:prstGeom prst="rect">
             <a:avLst/>
@@ -5904,14 +5952,14 @@
       </p:sp>
       <p:sp>
         <p:nvSpPr>
-          <p:cNvPr id="11" name="Rectangle 10"/>
+          <p:cNvPr id="12" name="Rectangle 11"/>
           <p:cNvSpPr/>
           <p:nvPr/>
         </p:nvSpPr>
         <p:spPr>
           <a:xfrm>
-            <a:off x="347472" y="804672"/>
-            <a:ext cx="82296" cy="987552"/>
+            <a:off x="347472" y="786384"/>
+            <a:ext cx="82296" cy="877824"/>
           </a:xfrm>
           <a:prstGeom prst="rect">
             <a:avLst/>
@@ -5947,13 +5995,13 @@
       </p:sp>
       <p:sp>
         <p:nvSpPr>
-          <p:cNvPr id="12" name="TextBox 11"/>
+          <p:cNvPr id="13" name="TextBox 12"/>
           <p:cNvSpPr txBox="1"/>
           <p:nvPr/>
         </p:nvSpPr>
         <p:spPr>
           <a:xfrm>
-            <a:off x="530352" y="877824"/>
+            <a:off x="530352" y="859536"/>
             <a:ext cx="2578608" cy="219456"/>
           </a:xfrm>
           <a:prstGeom prst="rect">
@@ -5982,13 +6030,13 @@
       </p:sp>
       <p:sp>
         <p:nvSpPr>
-          <p:cNvPr id="13" name="TextBox 12"/>
+          <p:cNvPr id="14" name="TextBox 13"/>
           <p:cNvSpPr txBox="1"/>
           <p:nvPr/>
         </p:nvSpPr>
         <p:spPr>
           <a:xfrm>
-            <a:off x="530352" y="1097280"/>
+            <a:off x="530352" y="1078992"/>
             <a:ext cx="2578608" cy="365760"/>
           </a:xfrm>
           <a:prstGeom prst="rect">
@@ -6017,13 +6065,13 @@
       </p:sp>
       <p:sp>
         <p:nvSpPr>
-          <p:cNvPr id="14" name="TextBox 13"/>
+          <p:cNvPr id="15" name="TextBox 14"/>
           <p:cNvSpPr txBox="1"/>
           <p:nvPr/>
         </p:nvSpPr>
         <p:spPr>
           <a:xfrm>
-            <a:off x="530352" y="1463040"/>
+            <a:off x="530352" y="1444752"/>
             <a:ext cx="2578608" cy="256032"/>
           </a:xfrm>
           <a:prstGeom prst="rect">
@@ -6052,14 +6100,14 @@
       </p:sp>
       <p:sp>
         <p:nvSpPr>
-          <p:cNvPr id="15" name="Rectangle 14"/>
+          <p:cNvPr id="16" name="Rectangle 15"/>
           <p:cNvSpPr/>
           <p:nvPr/>
         </p:nvSpPr>
         <p:spPr>
           <a:xfrm>
-            <a:off x="3273552" y="804672"/>
-            <a:ext cx="2834640" cy="987552"/>
+            <a:off x="3273552" y="786384"/>
+            <a:ext cx="2834640" cy="877824"/>
           </a:xfrm>
           <a:prstGeom prst="rect">
             <a:avLst/>
@@ -6097,14 +6145,14 @@
       </p:sp>
       <p:sp>
         <p:nvSpPr>
-          <p:cNvPr id="16" name="Rectangle 15"/>
+          <p:cNvPr id="17" name="Rectangle 16"/>
           <p:cNvSpPr/>
           <p:nvPr/>
         </p:nvSpPr>
         <p:spPr>
           <a:xfrm>
-            <a:off x="3273552" y="804672"/>
-            <a:ext cx="82296" cy="987552"/>
+            <a:off x="3273552" y="786384"/>
+            <a:ext cx="82296" cy="877824"/>
           </a:xfrm>
           <a:prstGeom prst="rect">
             <a:avLst/>
@@ -6140,13 +6188,13 @@
       </p:sp>
       <p:sp>
         <p:nvSpPr>
-          <p:cNvPr id="17" name="TextBox 16"/>
+          <p:cNvPr id="18" name="TextBox 17"/>
           <p:cNvSpPr txBox="1"/>
           <p:nvPr/>
         </p:nvSpPr>
         <p:spPr>
           <a:xfrm>
-            <a:off x="3456432" y="877824"/>
+            <a:off x="3456432" y="859536"/>
             <a:ext cx="2578608" cy="219456"/>
           </a:xfrm>
           <a:prstGeom prst="rect">
@@ -6175,13 +6223,13 @@
       </p:sp>
       <p:sp>
         <p:nvSpPr>
-          <p:cNvPr id="18" name="TextBox 17"/>
+          <p:cNvPr id="19" name="TextBox 18"/>
           <p:cNvSpPr txBox="1"/>
           <p:nvPr/>
         </p:nvSpPr>
         <p:spPr>
           <a:xfrm>
-            <a:off x="3456432" y="1097280"/>
+            <a:off x="3456432" y="1078992"/>
             <a:ext cx="2578608" cy="365760"/>
           </a:xfrm>
           <a:prstGeom prst="rect">
@@ -6210,13 +6258,13 @@
       </p:sp>
       <p:sp>
         <p:nvSpPr>
-          <p:cNvPr id="19" name="TextBox 18"/>
+          <p:cNvPr id="20" name="TextBox 19"/>
           <p:cNvSpPr txBox="1"/>
           <p:nvPr/>
         </p:nvSpPr>
         <p:spPr>
           <a:xfrm>
-            <a:off x="3456432" y="1463040"/>
+            <a:off x="3456432" y="1444752"/>
             <a:ext cx="2578608" cy="256032"/>
           </a:xfrm>
           <a:prstGeom prst="rect">
@@ -6245,14 +6293,14 @@
       </p:sp>
       <p:sp>
         <p:nvSpPr>
-          <p:cNvPr id="20" name="Rectangle 19"/>
+          <p:cNvPr id="21" name="Rectangle 20"/>
           <p:cNvSpPr/>
           <p:nvPr/>
         </p:nvSpPr>
         <p:spPr>
           <a:xfrm>
-            <a:off x="6199632" y="804672"/>
-            <a:ext cx="2834640" cy="987552"/>
+            <a:off x="6199632" y="786384"/>
+            <a:ext cx="2834640" cy="877824"/>
           </a:xfrm>
           <a:prstGeom prst="rect">
             <a:avLst/>
@@ -6290,14 +6338,14 @@
       </p:sp>
       <p:sp>
         <p:nvSpPr>
-          <p:cNvPr id="21" name="Rectangle 20"/>
+          <p:cNvPr id="22" name="Rectangle 21"/>
           <p:cNvSpPr/>
           <p:nvPr/>
         </p:nvSpPr>
         <p:spPr>
           <a:xfrm>
-            <a:off x="6199632" y="804672"/>
-            <a:ext cx="82296" cy="987552"/>
+            <a:off x="6199632" y="786384"/>
+            <a:ext cx="82296" cy="877824"/>
           </a:xfrm>
           <a:prstGeom prst="rect">
             <a:avLst/>
@@ -6333,13 +6381,13 @@
       </p:sp>
       <p:sp>
         <p:nvSpPr>
-          <p:cNvPr id="22" name="TextBox 21"/>
+          <p:cNvPr id="23" name="TextBox 22"/>
           <p:cNvSpPr txBox="1"/>
           <p:nvPr/>
         </p:nvSpPr>
         <p:spPr>
           <a:xfrm>
-            <a:off x="6382512" y="877824"/>
+            <a:off x="6382512" y="859536"/>
             <a:ext cx="2578608" cy="219456"/>
           </a:xfrm>
           <a:prstGeom prst="rect">
@@ -6368,13 +6416,13 @@
       </p:sp>
       <p:sp>
         <p:nvSpPr>
-          <p:cNvPr id="23" name="TextBox 22"/>
+          <p:cNvPr id="24" name="TextBox 23"/>
           <p:cNvSpPr txBox="1"/>
           <p:nvPr/>
         </p:nvSpPr>
         <p:spPr>
           <a:xfrm>
-            <a:off x="6382512" y="1097280"/>
+            <a:off x="6382512" y="1078992"/>
             <a:ext cx="2578608" cy="365760"/>
           </a:xfrm>
           <a:prstGeom prst="rect">
@@ -6403,13 +6451,13 @@
       </p:sp>
       <p:sp>
         <p:nvSpPr>
-          <p:cNvPr id="24" name="TextBox 23"/>
+          <p:cNvPr id="25" name="TextBox 24"/>
           <p:cNvSpPr txBox="1"/>
           <p:nvPr/>
         </p:nvSpPr>
         <p:spPr>
           <a:xfrm>
-            <a:off x="6382512" y="1463040"/>
+            <a:off x="6382512" y="1444752"/>
             <a:ext cx="2578608" cy="256032"/>
           </a:xfrm>
           <a:prstGeom prst="rect">
@@ -6438,14 +6486,14 @@
       </p:sp>
       <p:sp>
         <p:nvSpPr>
-          <p:cNvPr id="25" name="Rectangle 24"/>
+          <p:cNvPr id="26" name="Rectangle 25"/>
           <p:cNvSpPr/>
           <p:nvPr/>
         </p:nvSpPr>
         <p:spPr>
           <a:xfrm>
-            <a:off x="9125712" y="804672"/>
-            <a:ext cx="2706624" cy="987552"/>
+            <a:off x="9125712" y="786384"/>
+            <a:ext cx="2706624" cy="877824"/>
           </a:xfrm>
           <a:prstGeom prst="rect">
             <a:avLst/>
@@ -6483,14 +6531,14 @@
       </p:sp>
       <p:sp>
         <p:nvSpPr>
-          <p:cNvPr id="26" name="Rectangle 25"/>
+          <p:cNvPr id="27" name="Rectangle 26"/>
           <p:cNvSpPr/>
           <p:nvPr/>
         </p:nvSpPr>
         <p:spPr>
           <a:xfrm>
-            <a:off x="9125712" y="804672"/>
-            <a:ext cx="82296" cy="987552"/>
+            <a:off x="9125712" y="786384"/>
+            <a:ext cx="82296" cy="877824"/>
           </a:xfrm>
           <a:prstGeom prst="rect">
             <a:avLst/>
@@ -6526,13 +6574,13 @@
       </p:sp>
       <p:sp>
         <p:nvSpPr>
-          <p:cNvPr id="27" name="TextBox 26"/>
+          <p:cNvPr id="28" name="TextBox 27"/>
           <p:cNvSpPr txBox="1"/>
           <p:nvPr/>
         </p:nvSpPr>
         <p:spPr>
           <a:xfrm>
-            <a:off x="9308592" y="877824"/>
+            <a:off x="9308592" y="859536"/>
             <a:ext cx="2450592" cy="219456"/>
           </a:xfrm>
           <a:prstGeom prst="rect">
@@ -6561,13 +6609,13 @@
       </p:sp>
       <p:sp>
         <p:nvSpPr>
-          <p:cNvPr id="28" name="TextBox 27"/>
+          <p:cNvPr id="29" name="TextBox 28"/>
           <p:cNvSpPr txBox="1"/>
           <p:nvPr/>
         </p:nvSpPr>
         <p:spPr>
           <a:xfrm>
-            <a:off x="9308592" y="1097280"/>
+            <a:off x="9308592" y="1078992"/>
             <a:ext cx="2450592" cy="365760"/>
           </a:xfrm>
           <a:prstGeom prst="rect">
@@ -6596,13 +6644,13 @@
       </p:sp>
       <p:sp>
         <p:nvSpPr>
-          <p:cNvPr id="29" name="TextBox 28"/>
+          <p:cNvPr id="30" name="TextBox 29"/>
           <p:cNvSpPr txBox="1"/>
           <p:nvPr/>
         </p:nvSpPr>
         <p:spPr>
           <a:xfrm>
-            <a:off x="9308592" y="1463040"/>
+            <a:off x="9308592" y="1444752"/>
             <a:ext cx="2450592" cy="256032"/>
           </a:xfrm>
           <a:prstGeom prst="rect">
@@ -6631,14 +6679,14 @@
       </p:sp>
       <p:sp>
         <p:nvSpPr>
-          <p:cNvPr id="30" name="TextBox 29"/>
+          <p:cNvPr id="31" name="TextBox 30"/>
           <p:cNvSpPr txBox="1"/>
           <p:nvPr/>
         </p:nvSpPr>
         <p:spPr>
           <a:xfrm>
-            <a:off x="347472" y="1920240"/>
-            <a:ext cx="5760720" cy="274320"/>
+            <a:off x="347472" y="1792224"/>
+            <a:ext cx="5760720" cy="292608"/>
           </a:xfrm>
           <a:prstGeom prst="rect">
             <a:avLst/>
@@ -6666,22 +6714,22 @@
       </p:sp>
       <p:pic>
         <p:nvPicPr>
-          <p:cNvPr id="31" name="Picture 30" descr="data_brands.png"/>
+          <p:cNvPr id="32" name="Picture 31" descr="data_brands.png"/>
           <p:cNvPicPr>
             <a:picLocks noChangeAspect="1"/>
           </p:cNvPicPr>
           <p:nvPr/>
         </p:nvPicPr>
         <p:blipFill>
-          <a:blip r:embed="rId2"/>
+          <a:blip r:embed="rId3"/>
           <a:stretch>
             <a:fillRect/>
           </a:stretch>
         </p:blipFill>
         <p:spPr>
           <a:xfrm>
-            <a:off x="201168" y="2176272"/>
-            <a:ext cx="5852160" cy="2331720"/>
+            <a:off x="201168" y="2395728"/>
+            <a:ext cx="5852160" cy="1995055"/>
           </a:xfrm>
           <a:prstGeom prst="rect">
             <a:avLst/>
@@ -6690,14 +6738,14 @@
       </p:pic>
       <p:sp>
         <p:nvSpPr>
-          <p:cNvPr id="32" name="TextBox 31"/>
+          <p:cNvPr id="33" name="TextBox 32"/>
           <p:cNvSpPr txBox="1"/>
           <p:nvPr/>
         </p:nvSpPr>
         <p:spPr>
           <a:xfrm>
-            <a:off x="6217920" y="1920240"/>
-            <a:ext cx="5577840" cy="274320"/>
+            <a:off x="6217920" y="1792224"/>
+            <a:ext cx="5577840" cy="292608"/>
           </a:xfrm>
           <a:prstGeom prst="rect">
             <a:avLst/>
@@ -6725,15 +6773,15 @@
       </p:sp>
       <p:graphicFrame>
         <p:nvGraphicFramePr>
-          <p:cNvPr id="33" name="Table 32"/>
+          <p:cNvPr id="34" name="Table 33"/>
           <p:cNvGraphicFramePr>
             <a:graphicFrameLocks noGrp="1"/>
           </p:cNvGraphicFramePr>
           <p:nvPr/>
         </p:nvGraphicFramePr>
         <p:xfrm>
-          <a:off x="6217920" y="2212848"/>
-          <a:ext cx="5623560" cy="2331720"/>
+          <a:off x="6217920" y="2395728"/>
+          <a:ext cx="5623560" cy="1874519"/>
         </p:xfrm>
         <a:graphic>
           <a:graphicData uri="http://schemas.openxmlformats.org/drawingml/2006/table">
@@ -6749,7 +6797,7 @@
                 <a:gridCol w="960120"/>
                 <a:gridCol w="1005840"/>
               </a:tblGrid>
-              <a:tr h="291465">
+              <a:tr h="267788">
                 <a:tc>
                   <a:txBody>
                     <a:bodyPr/>
@@ -6889,7 +6937,7 @@
                   </a:tcPr>
                 </a:tc>
               </a:tr>
-              <a:tr h="291465">
+              <a:tr h="267788">
                 <a:tc>
                   <a:txBody>
                     <a:bodyPr/>
@@ -7029,7 +7077,7 @@
                   </a:tcPr>
                 </a:tc>
               </a:tr>
-              <a:tr h="291465">
+              <a:tr h="267788">
                 <a:tc>
                   <a:txBody>
                     <a:bodyPr/>
@@ -7169,7 +7217,7 @@
                   </a:tcPr>
                 </a:tc>
               </a:tr>
-              <a:tr h="291465">
+              <a:tr h="267788">
                 <a:tc>
                   <a:txBody>
                     <a:bodyPr/>
@@ -7309,7 +7357,7 @@
                   </a:tcPr>
                 </a:tc>
               </a:tr>
-              <a:tr h="291465">
+              <a:tr h="267788">
                 <a:tc>
                   <a:txBody>
                     <a:bodyPr/>
@@ -7449,7 +7497,7 @@
                   </a:tcPr>
                 </a:tc>
               </a:tr>
-              <a:tr h="291465">
+              <a:tr h="267788">
                 <a:tc>
                   <a:txBody>
                     <a:bodyPr/>
@@ -7589,7 +7637,7 @@
                   </a:tcPr>
                 </a:tc>
               </a:tr>
-              <a:tr h="291465">
+              <a:tr h="267791">
                 <a:tc>
                   <a:txBody>
                     <a:bodyPr/>
@@ -7603,7 +7651,7 @@
                           </a:solidFill>
                           <a:latin typeface="Calibri"/>
                         </a:rPr>
-                        <a:t>Mr Pasta</a:t>
+                        <a:t>Knorr</a:t>
                       </a:r>
                     </a:p>
                   </a:txBody>
@@ -7626,7 +7674,7 @@
                           </a:solidFill>
                           <a:latin typeface="Calibri"/>
                         </a:rPr>
-                        <a:t>1.9%</a:t>
+                        <a:t>0.1%</a:t>
                       </a:r>
                     </a:p>
                   </a:txBody>
@@ -7649,7 +7697,7 @@
                           </a:solidFill>
                           <a:latin typeface="Calibri"/>
                         </a:rPr>
-                        <a:t>1.5%</a:t>
+                        <a:t>0.6%</a:t>
                       </a:r>
                     </a:p>
                   </a:txBody>
@@ -7668,34 +7716,11 @@
                       <a:r>
                         <a:rPr sz="1300" b="0">
                           <a:solidFill>
-                            <a:srgbClr val="B02828"/>
+                            <a:srgbClr val="1B7A3A"/>
                           </a:solidFill>
                           <a:latin typeface="Calibri"/>
                         </a:rPr>
-                        <a:t>-2.3pp</a:t>
-                      </a:r>
-                    </a:p>
-                  </a:txBody>
-                  <a:tcPr>
-                    <a:solidFill>
-                      <a:srgbClr val="FFFFFF"/>
-                    </a:solidFill>
-                  </a:tcPr>
-                </a:tc>
-                <a:tc>
-                  <a:txBody>
-                    <a:bodyPr/>
-                    <a:lstStyle/>
-                    <a:p>
-                      <a:pPr algn="r"/>
-                      <a:r>
-                        <a:rPr sz="1300" b="0">
-                          <a:solidFill>
-                            <a:srgbClr val="B02828"/>
-                          </a:solidFill>
-                          <a:latin typeface="Calibri"/>
-                        </a:rPr>
-                        <a:t>-50.7%</a:t>
+                        <a:t>+0.1pp</a:t>
                       </a:r>
                     </a:p>
                   </a:txBody>
@@ -7718,130 +7743,13 @@
                           </a:solidFill>
                           <a:latin typeface="Calibri"/>
                         </a:rPr>
-                        <a:t>R147</a:t>
+                        <a:t>n/a</a:t>
                       </a:r>
                     </a:p>
                   </a:txBody>
                   <a:tcPr>
                     <a:solidFill>
                       <a:srgbClr val="FFFFFF"/>
-                    </a:solidFill>
-                  </a:tcPr>
-                </a:tc>
-              </a:tr>
-              <a:tr h="291465">
-                <a:tc>
-                  <a:txBody>
-                    <a:bodyPr/>
-                    <a:lstStyle/>
-                    <a:p>
-                      <a:pPr algn="l"/>
-                      <a:r>
-                        <a:rPr sz="1300" b="1">
-                          <a:solidFill>
-                            <a:srgbClr val="111111"/>
-                          </a:solidFill>
-                          <a:latin typeface="Calibri"/>
-                        </a:rPr>
-                        <a:t>Knorr</a:t>
-                      </a:r>
-                    </a:p>
-                  </a:txBody>
-                  <a:tcPr>
-                    <a:solidFill>
-                      <a:srgbClr val="EEF2F6"/>
-                    </a:solidFill>
-                  </a:tcPr>
-                </a:tc>
-                <a:tc>
-                  <a:txBody>
-                    <a:bodyPr/>
-                    <a:lstStyle/>
-                    <a:p>
-                      <a:pPr algn="r"/>
-                      <a:r>
-                        <a:rPr sz="1300" b="0">
-                          <a:solidFill>
-                            <a:srgbClr val="111111"/>
-                          </a:solidFill>
-                          <a:latin typeface="Calibri"/>
-                        </a:rPr>
-                        <a:t>0.1%</a:t>
-                      </a:r>
-                    </a:p>
-                  </a:txBody>
-                  <a:tcPr>
-                    <a:solidFill>
-                      <a:srgbClr val="EEF2F6"/>
-                    </a:solidFill>
-                  </a:tcPr>
-                </a:tc>
-                <a:tc>
-                  <a:txBody>
-                    <a:bodyPr/>
-                    <a:lstStyle/>
-                    <a:p>
-                      <a:pPr algn="r"/>
-                      <a:r>
-                        <a:rPr sz="1300" b="0">
-                          <a:solidFill>
-                            <a:srgbClr val="111111"/>
-                          </a:solidFill>
-                          <a:latin typeface="Calibri"/>
-                        </a:rPr>
-                        <a:t>0.6%</a:t>
-                      </a:r>
-                    </a:p>
-                  </a:txBody>
-                  <a:tcPr>
-                    <a:solidFill>
-                      <a:srgbClr val="EEF2F6"/>
-                    </a:solidFill>
-                  </a:tcPr>
-                </a:tc>
-                <a:tc>
-                  <a:txBody>
-                    <a:bodyPr/>
-                    <a:lstStyle/>
-                    <a:p>
-                      <a:pPr algn="r"/>
-                      <a:r>
-                        <a:rPr sz="1300" b="0">
-                          <a:solidFill>
-                            <a:srgbClr val="1B7A3A"/>
-                          </a:solidFill>
-                          <a:latin typeface="Calibri"/>
-                        </a:rPr>
-                        <a:t>+0.1pp</a:t>
-                      </a:r>
-                    </a:p>
-                  </a:txBody>
-                  <a:tcPr>
-                    <a:solidFill>
-                      <a:srgbClr val="EEF2F6"/>
-                    </a:solidFill>
-                  </a:tcPr>
-                </a:tc>
-                <a:tc>
-                  <a:txBody>
-                    <a:bodyPr/>
-                    <a:lstStyle/>
-                    <a:p>
-                      <a:pPr algn="r"/>
-                      <a:r>
-                        <a:rPr sz="1300" b="0">
-                          <a:solidFill>
-                            <a:srgbClr val="111111"/>
-                          </a:solidFill>
-                          <a:latin typeface="Calibri"/>
-                        </a:rPr>
-                        <a:t>n/a</a:t>
-                      </a:r>
-                    </a:p>
-                  </a:txBody>
-                  <a:tcPr>
-                    <a:solidFill>
-                      <a:srgbClr val="EEF2F6"/>
                     </a:solidFill>
                   </a:tcPr>
                 </a:tc>
@@ -7864,7 +7772,7 @@
                   </a:txBody>
                   <a:tcPr>
                     <a:solidFill>
-                      <a:srgbClr val="EEF2F6"/>
+                      <a:srgbClr val="FFFFFF"/>
                     </a:solidFill>
                   </a:tcPr>
                 </a:tc>
@@ -7875,14 +7783,14 @@
       </p:graphicFrame>
       <p:sp>
         <p:nvSpPr>
-          <p:cNvPr id="34" name="TextBox 33"/>
+          <p:cNvPr id="35" name="TextBox 34"/>
           <p:cNvSpPr txBox="1"/>
           <p:nvPr/>
         </p:nvSpPr>
         <p:spPr>
           <a:xfrm>
-            <a:off x="347472" y="4590288"/>
-            <a:ext cx="5760720" cy="256032"/>
+            <a:off x="347472" y="4572000"/>
+            <a:ext cx="5760720" cy="292608"/>
           </a:xfrm>
           <a:prstGeom prst="rect">
             <a:avLst/>
@@ -7908,40 +7816,788 @@
           </a:p>
         </p:txBody>
       </p:sp>
-      <p:pic>
-        <p:nvPicPr>
-          <p:cNvPr id="35" name="Picture 34" descr="data_price.png"/>
-          <p:cNvPicPr>
-            <a:picLocks noChangeAspect="1"/>
-          </p:cNvPicPr>
-          <p:nvPr/>
-        </p:nvPicPr>
-        <p:blipFill>
-          <a:blip r:embed="rId3"/>
-          <a:stretch>
-            <a:fillRect/>
-          </a:stretch>
-        </p:blipFill>
-        <p:spPr>
-          <a:xfrm>
-            <a:off x="182880" y="4828032"/>
-            <a:ext cx="5852160" cy="1627632"/>
-          </a:xfrm>
-          <a:prstGeom prst="rect">
-            <a:avLst/>
-          </a:prstGeom>
-        </p:spPr>
-      </p:pic>
-      <p:sp>
-        <p:nvSpPr>
-          <p:cNvPr id="36" name="TextBox 35"/>
+      <p:sp>
+        <p:nvSpPr>
+          <p:cNvPr id="36" name="Rectangle 35"/>
+          <p:cNvSpPr/>
+          <p:nvPr/>
+        </p:nvSpPr>
+        <p:spPr>
+          <a:xfrm>
+            <a:off x="347472" y="4974336"/>
+            <a:ext cx="2788920" cy="676656"/>
+          </a:xfrm>
+          <a:prstGeom prst="rect">
+            <a:avLst/>
+          </a:prstGeom>
+          <a:solidFill>
+            <a:srgbClr val="F3F5F7"/>
+          </a:solidFill>
+          <a:ln w="12700">
+            <a:solidFill>
+              <a:srgbClr val="C8D0D8"/>
+            </a:solidFill>
+          </a:ln>
+        </p:spPr>
+        <p:style>
+          <a:lnRef idx="1">
+            <a:schemeClr val="accent1"/>
+          </a:lnRef>
+          <a:fillRef idx="3">
+            <a:schemeClr val="accent1"/>
+          </a:fillRef>
+          <a:effectRef idx="2">
+            <a:schemeClr val="accent1"/>
+          </a:effectRef>
+          <a:fontRef idx="minor">
+            <a:schemeClr val="lt1"/>
+          </a:fontRef>
+        </p:style>
+        <p:txBody>
+          <a:bodyPr rtlCol="0" anchor="ctr"/>
+          <a:lstStyle/>
+          <a:p>
+            <a:pPr algn="ctr"/>
+          </a:p>
+        </p:txBody>
+      </p:sp>
+      <p:sp>
+        <p:nvSpPr>
+          <p:cNvPr id="37" name="Rectangle 36"/>
+          <p:cNvSpPr/>
+          <p:nvPr/>
+        </p:nvSpPr>
+        <p:spPr>
+          <a:xfrm>
+            <a:off x="347472" y="4974336"/>
+            <a:ext cx="82296" cy="676656"/>
+          </a:xfrm>
+          <a:prstGeom prst="rect">
+            <a:avLst/>
+          </a:prstGeom>
+          <a:solidFill>
+            <a:srgbClr val="1F5FA8"/>
+          </a:solidFill>
+          <a:ln>
+            <a:noFill/>
+          </a:ln>
+        </p:spPr>
+        <p:style>
+          <a:lnRef idx="1">
+            <a:schemeClr val="accent1"/>
+          </a:lnRef>
+          <a:fillRef idx="3">
+            <a:schemeClr val="accent1"/>
+          </a:fillRef>
+          <a:effectRef idx="2">
+            <a:schemeClr val="accent1"/>
+          </a:effectRef>
+          <a:fontRef idx="minor">
+            <a:schemeClr val="lt1"/>
+          </a:fontRef>
+        </p:style>
+        <p:txBody>
+          <a:bodyPr rtlCol="0" anchor="ctr"/>
+          <a:lstStyle/>
+          <a:p>
+            <a:pPr algn="ctr"/>
+          </a:p>
+        </p:txBody>
+      </p:sp>
+      <p:sp>
+        <p:nvSpPr>
+          <p:cNvPr id="38" name="TextBox 37"/>
           <p:cNvSpPr txBox="1"/>
           <p:nvPr/>
         </p:nvSpPr>
         <p:spPr>
           <a:xfrm>
-            <a:off x="6217920" y="4590288"/>
-            <a:ext cx="5577840" cy="256032"/>
+            <a:off x="530352" y="5020056"/>
+            <a:ext cx="2487168" cy="182880"/>
+          </a:xfrm>
+          <a:prstGeom prst="rect">
+            <a:avLst/>
+          </a:prstGeom>
+          <a:noFill/>
+        </p:spPr>
+        <p:txBody>
+          <a:bodyPr wrap="square">
+            <a:spAutoFit/>
+          </a:bodyPr>
+          <a:lstStyle/>
+          <a:p>
+            <a:pPr algn="l"/>
+            <a:r>
+              <a:rPr sz="1100" b="1">
+                <a:solidFill>
+                  <a:srgbClr val="3D4A55"/>
+                </a:solidFill>
+                <a:latin typeface="Calibri"/>
+              </a:rPr>
+              <a:t>ROKA</a:t>
+            </a:r>
+          </a:p>
+        </p:txBody>
+      </p:sp>
+      <p:sp>
+        <p:nvSpPr>
+          <p:cNvPr id="39" name="TextBox 38"/>
+          <p:cNvSpPr txBox="1"/>
+          <p:nvPr/>
+        </p:nvSpPr>
+        <p:spPr>
+          <a:xfrm>
+            <a:off x="530352" y="5193792"/>
+            <a:ext cx="2487168" cy="237744"/>
+          </a:xfrm>
+          <a:prstGeom prst="rect">
+            <a:avLst/>
+          </a:prstGeom>
+          <a:noFill/>
+        </p:spPr>
+        <p:txBody>
+          <a:bodyPr wrap="square">
+            <a:spAutoFit/>
+          </a:bodyPr>
+          <a:lstStyle/>
+          <a:p>
+            <a:pPr algn="l"/>
+            <a:r>
+              <a:rPr sz="2000" b="1">
+                <a:solidFill>
+                  <a:srgbClr val="122A4A"/>
+                </a:solidFill>
+                <a:latin typeface="Calibri"/>
+              </a:rPr>
+              <a:t>R5.88</a:t>
+            </a:r>
+          </a:p>
+        </p:txBody>
+      </p:sp>
+      <p:sp>
+        <p:nvSpPr>
+          <p:cNvPr id="40" name="TextBox 39"/>
+          <p:cNvSpPr txBox="1"/>
+          <p:nvPr/>
+        </p:nvSpPr>
+        <p:spPr>
+          <a:xfrm>
+            <a:off x="530352" y="5431536"/>
+            <a:ext cx="2487168" cy="182880"/>
+          </a:xfrm>
+          <a:prstGeom prst="rect">
+            <a:avLst/>
+          </a:prstGeom>
+          <a:noFill/>
+        </p:spPr>
+        <p:txBody>
+          <a:bodyPr wrap="square">
+            <a:spAutoFit/>
+          </a:bodyPr>
+          <a:lstStyle/>
+          <a:p>
+            <a:pPr algn="l"/>
+            <a:r>
+              <a:rPr sz="1200" b="0">
+                <a:solidFill>
+                  <a:srgbClr val="111111"/>
+                </a:solidFill>
+                <a:latin typeface="Calibri"/>
+              </a:rPr>
+              <a:t>Value sachet</a:t>
+            </a:r>
+          </a:p>
+        </p:txBody>
+      </p:sp>
+      <p:sp>
+        <p:nvSpPr>
+          <p:cNvPr id="41" name="Rectangle 40"/>
+          <p:cNvSpPr/>
+          <p:nvPr/>
+        </p:nvSpPr>
+        <p:spPr>
+          <a:xfrm>
+            <a:off x="3273552" y="4974336"/>
+            <a:ext cx="2788920" cy="676656"/>
+          </a:xfrm>
+          <a:prstGeom prst="rect">
+            <a:avLst/>
+          </a:prstGeom>
+          <a:solidFill>
+            <a:srgbClr val="F3F5F7"/>
+          </a:solidFill>
+          <a:ln w="12700">
+            <a:solidFill>
+              <a:srgbClr val="C8D0D8"/>
+            </a:solidFill>
+          </a:ln>
+        </p:spPr>
+        <p:style>
+          <a:lnRef idx="1">
+            <a:schemeClr val="accent1"/>
+          </a:lnRef>
+          <a:fillRef idx="3">
+            <a:schemeClr val="accent1"/>
+          </a:fillRef>
+          <a:effectRef idx="2">
+            <a:schemeClr val="accent1"/>
+          </a:effectRef>
+          <a:fontRef idx="minor">
+            <a:schemeClr val="lt1"/>
+          </a:fontRef>
+        </p:style>
+        <p:txBody>
+          <a:bodyPr rtlCol="0" anchor="ctr"/>
+          <a:lstStyle/>
+          <a:p>
+            <a:pPr algn="ctr"/>
+          </a:p>
+        </p:txBody>
+      </p:sp>
+      <p:sp>
+        <p:nvSpPr>
+          <p:cNvPr id="42" name="Rectangle 41"/>
+          <p:cNvSpPr/>
+          <p:nvPr/>
+        </p:nvSpPr>
+        <p:spPr>
+          <a:xfrm>
+            <a:off x="3273552" y="4974336"/>
+            <a:ext cx="82296" cy="676656"/>
+          </a:xfrm>
+          <a:prstGeom prst="rect">
+            <a:avLst/>
+          </a:prstGeom>
+          <a:solidFill>
+            <a:srgbClr val="1F5FA8"/>
+          </a:solidFill>
+          <a:ln>
+            <a:noFill/>
+          </a:ln>
+        </p:spPr>
+        <p:style>
+          <a:lnRef idx="1">
+            <a:schemeClr val="accent1"/>
+          </a:lnRef>
+          <a:fillRef idx="3">
+            <a:schemeClr val="accent1"/>
+          </a:fillRef>
+          <a:effectRef idx="2">
+            <a:schemeClr val="accent1"/>
+          </a:effectRef>
+          <a:fontRef idx="minor">
+            <a:schemeClr val="lt1"/>
+          </a:fontRef>
+        </p:style>
+        <p:txBody>
+          <a:bodyPr rtlCol="0" anchor="ctr"/>
+          <a:lstStyle/>
+          <a:p>
+            <a:pPr algn="ctr"/>
+          </a:p>
+        </p:txBody>
+      </p:sp>
+      <p:sp>
+        <p:nvSpPr>
+          <p:cNvPr id="43" name="TextBox 42"/>
+          <p:cNvSpPr txBox="1"/>
+          <p:nvPr/>
+        </p:nvSpPr>
+        <p:spPr>
+          <a:xfrm>
+            <a:off x="3456432" y="5020056"/>
+            <a:ext cx="2487168" cy="182880"/>
+          </a:xfrm>
+          <a:prstGeom prst="rect">
+            <a:avLst/>
+          </a:prstGeom>
+          <a:noFill/>
+        </p:spPr>
+        <p:txBody>
+          <a:bodyPr wrap="square">
+            <a:spAutoFit/>
+          </a:bodyPr>
+          <a:lstStyle/>
+          <a:p>
+            <a:pPr algn="l"/>
+            <a:r>
+              <a:rPr sz="1100" b="1">
+                <a:solidFill>
+                  <a:srgbClr val="3D4A55"/>
+                </a:solidFill>
+                <a:latin typeface="Calibri"/>
+              </a:rPr>
+              <a:t>KELLOGG'S</a:t>
+            </a:r>
+          </a:p>
+        </p:txBody>
+      </p:sp>
+      <p:sp>
+        <p:nvSpPr>
+          <p:cNvPr id="44" name="TextBox 43"/>
+          <p:cNvSpPr txBox="1"/>
+          <p:nvPr/>
+        </p:nvSpPr>
+        <p:spPr>
+          <a:xfrm>
+            <a:off x="3456432" y="5193792"/>
+            <a:ext cx="2487168" cy="237744"/>
+          </a:xfrm>
+          <a:prstGeom prst="rect">
+            <a:avLst/>
+          </a:prstGeom>
+          <a:noFill/>
+        </p:spPr>
+        <p:txBody>
+          <a:bodyPr wrap="square">
+            <a:spAutoFit/>
+          </a:bodyPr>
+          <a:lstStyle/>
+          <a:p>
+            <a:pPr algn="l"/>
+            <a:r>
+              <a:rPr sz="2000" b="1">
+                <a:solidFill>
+                  <a:srgbClr val="122A4A"/>
+                </a:solidFill>
+                <a:latin typeface="Calibri"/>
+              </a:rPr>
+              <a:t>R6.09</a:t>
+            </a:r>
+          </a:p>
+        </p:txBody>
+      </p:sp>
+      <p:sp>
+        <p:nvSpPr>
+          <p:cNvPr id="45" name="TextBox 44"/>
+          <p:cNvSpPr txBox="1"/>
+          <p:nvPr/>
+        </p:nvSpPr>
+        <p:spPr>
+          <a:xfrm>
+            <a:off x="3456432" y="5431536"/>
+            <a:ext cx="2487168" cy="182880"/>
+          </a:xfrm>
+          <a:prstGeom prst="rect">
+            <a:avLst/>
+          </a:prstGeom>
+          <a:noFill/>
+        </p:spPr>
+        <p:txBody>
+          <a:bodyPr wrap="square">
+            <a:spAutoFit/>
+          </a:bodyPr>
+          <a:lstStyle/>
+          <a:p>
+            <a:pPr algn="l"/>
+            <a:r>
+              <a:rPr sz="1200" b="0">
+                <a:solidFill>
+                  <a:srgbClr val="111111"/>
+                </a:solidFill>
+                <a:latin typeface="Calibri"/>
+              </a:rPr>
+              <a:t>Maggi R6.79  ·  Indomie R7.90</a:t>
+            </a:r>
+          </a:p>
+        </p:txBody>
+      </p:sp>
+      <p:sp>
+        <p:nvSpPr>
+          <p:cNvPr id="46" name="Rectangle 45"/>
+          <p:cNvSpPr/>
+          <p:nvPr/>
+        </p:nvSpPr>
+        <p:spPr>
+          <a:xfrm>
+            <a:off x="347472" y="5724144"/>
+            <a:ext cx="2788920" cy="676656"/>
+          </a:xfrm>
+          <a:prstGeom prst="rect">
+            <a:avLst/>
+          </a:prstGeom>
+          <a:solidFill>
+            <a:srgbClr val="F3F5F7"/>
+          </a:solidFill>
+          <a:ln w="12700">
+            <a:solidFill>
+              <a:srgbClr val="C8D0D8"/>
+            </a:solidFill>
+          </a:ln>
+        </p:spPr>
+        <p:style>
+          <a:lnRef idx="1">
+            <a:schemeClr val="accent1"/>
+          </a:lnRef>
+          <a:fillRef idx="3">
+            <a:schemeClr val="accent1"/>
+          </a:fillRef>
+          <a:effectRef idx="2">
+            <a:schemeClr val="accent1"/>
+          </a:effectRef>
+          <a:fontRef idx="minor">
+            <a:schemeClr val="lt1"/>
+          </a:fontRef>
+        </p:style>
+        <p:txBody>
+          <a:bodyPr rtlCol="0" anchor="ctr"/>
+          <a:lstStyle/>
+          <a:p>
+            <a:pPr algn="ctr"/>
+          </a:p>
+        </p:txBody>
+      </p:sp>
+      <p:sp>
+        <p:nvSpPr>
+          <p:cNvPr id="47" name="Rectangle 46"/>
+          <p:cNvSpPr/>
+          <p:nvPr/>
+        </p:nvSpPr>
+        <p:spPr>
+          <a:xfrm>
+            <a:off x="347472" y="5724144"/>
+            <a:ext cx="82296" cy="676656"/>
+          </a:xfrm>
+          <a:prstGeom prst="rect">
+            <a:avLst/>
+          </a:prstGeom>
+          <a:solidFill>
+            <a:srgbClr val="0E7C7B"/>
+          </a:solidFill>
+          <a:ln>
+            <a:noFill/>
+          </a:ln>
+        </p:spPr>
+        <p:style>
+          <a:lnRef idx="1">
+            <a:schemeClr val="accent1"/>
+          </a:lnRef>
+          <a:fillRef idx="3">
+            <a:schemeClr val="accent1"/>
+          </a:fillRef>
+          <a:effectRef idx="2">
+            <a:schemeClr val="accent1"/>
+          </a:effectRef>
+          <a:fontRef idx="minor">
+            <a:schemeClr val="lt1"/>
+          </a:fontRef>
+        </p:style>
+        <p:txBody>
+          <a:bodyPr rtlCol="0" anchor="ctr"/>
+          <a:lstStyle/>
+          <a:p>
+            <a:pPr algn="ctr"/>
+          </a:p>
+        </p:txBody>
+      </p:sp>
+      <p:sp>
+        <p:nvSpPr>
+          <p:cNvPr id="48" name="TextBox 47"/>
+          <p:cNvSpPr txBox="1"/>
+          <p:nvPr/>
+        </p:nvSpPr>
+        <p:spPr>
+          <a:xfrm>
+            <a:off x="530352" y="5769864"/>
+            <a:ext cx="2487168" cy="182880"/>
+          </a:xfrm>
+          <a:prstGeom prst="rect">
+            <a:avLst/>
+          </a:prstGeom>
+          <a:noFill/>
+        </p:spPr>
+        <p:txBody>
+          <a:bodyPr wrap="square">
+            <a:spAutoFit/>
+          </a:bodyPr>
+          <a:lstStyle/>
+          <a:p>
+            <a:pPr algn="l"/>
+            <a:r>
+              <a:rPr sz="1100" b="1">
+                <a:solidFill>
+                  <a:srgbClr val="3D4A55"/>
+                </a:solidFill>
+                <a:latin typeface="Calibri"/>
+              </a:rPr>
+              <a:t>SAMYANG</a:t>
+            </a:r>
+          </a:p>
+        </p:txBody>
+      </p:sp>
+      <p:sp>
+        <p:nvSpPr>
+          <p:cNvPr id="49" name="TextBox 48"/>
+          <p:cNvSpPr txBox="1"/>
+          <p:nvPr/>
+        </p:nvSpPr>
+        <p:spPr>
+          <a:xfrm>
+            <a:off x="530352" y="5943600"/>
+            <a:ext cx="2487168" cy="237744"/>
+          </a:xfrm>
+          <a:prstGeom prst="rect">
+            <a:avLst/>
+          </a:prstGeom>
+          <a:noFill/>
+        </p:spPr>
+        <p:txBody>
+          <a:bodyPr wrap="square">
+            <a:spAutoFit/>
+          </a:bodyPr>
+          <a:lstStyle/>
+          <a:p>
+            <a:pPr algn="l"/>
+            <a:r>
+              <a:rPr sz="2000" b="1">
+                <a:solidFill>
+                  <a:srgbClr val="122A4A"/>
+                </a:solidFill>
+                <a:latin typeface="Calibri"/>
+              </a:rPr>
+              <a:t>R39.24</a:t>
+            </a:r>
+          </a:p>
+        </p:txBody>
+      </p:sp>
+      <p:sp>
+        <p:nvSpPr>
+          <p:cNvPr id="50" name="TextBox 49"/>
+          <p:cNvSpPr txBox="1"/>
+          <p:nvPr/>
+        </p:nvSpPr>
+        <p:spPr>
+          <a:xfrm>
+            <a:off x="530352" y="6181344"/>
+            <a:ext cx="2487168" cy="182880"/>
+          </a:xfrm>
+          <a:prstGeom prst="rect">
+            <a:avLst/>
+          </a:prstGeom>
+          <a:noFill/>
+        </p:spPr>
+        <p:txBody>
+          <a:bodyPr wrap="square">
+            <a:spAutoFit/>
+          </a:bodyPr>
+          <a:lstStyle/>
+          <a:p>
+            <a:pPr algn="l"/>
+            <a:r>
+              <a:rPr sz="1200" b="0">
+                <a:solidFill>
+                  <a:srgbClr val="111111"/>
+                </a:solidFill>
+                <a:latin typeface="Calibri"/>
+              </a:rPr>
+              <a:t>Ramen / cup</a:t>
+            </a:r>
+          </a:p>
+        </p:txBody>
+      </p:sp>
+      <p:sp>
+        <p:nvSpPr>
+          <p:cNvPr id="51" name="Rectangle 50"/>
+          <p:cNvSpPr/>
+          <p:nvPr/>
+        </p:nvSpPr>
+        <p:spPr>
+          <a:xfrm>
+            <a:off x="3273552" y="5724144"/>
+            <a:ext cx="2788920" cy="676656"/>
+          </a:xfrm>
+          <a:prstGeom prst="rect">
+            <a:avLst/>
+          </a:prstGeom>
+          <a:solidFill>
+            <a:srgbClr val="F3F5F7"/>
+          </a:solidFill>
+          <a:ln w="12700">
+            <a:solidFill>
+              <a:srgbClr val="C8D0D8"/>
+            </a:solidFill>
+          </a:ln>
+        </p:spPr>
+        <p:style>
+          <a:lnRef idx="1">
+            <a:schemeClr val="accent1"/>
+          </a:lnRef>
+          <a:fillRef idx="3">
+            <a:schemeClr val="accent1"/>
+          </a:fillRef>
+          <a:effectRef idx="2">
+            <a:schemeClr val="accent1"/>
+          </a:effectRef>
+          <a:fontRef idx="minor">
+            <a:schemeClr val="lt1"/>
+          </a:fontRef>
+        </p:style>
+        <p:txBody>
+          <a:bodyPr rtlCol="0" anchor="ctr"/>
+          <a:lstStyle/>
+          <a:p>
+            <a:pPr algn="ctr"/>
+          </a:p>
+        </p:txBody>
+      </p:sp>
+      <p:sp>
+        <p:nvSpPr>
+          <p:cNvPr id="52" name="Rectangle 51"/>
+          <p:cNvSpPr/>
+          <p:nvPr/>
+        </p:nvSpPr>
+        <p:spPr>
+          <a:xfrm>
+            <a:off x="3273552" y="5724144"/>
+            <a:ext cx="82296" cy="676656"/>
+          </a:xfrm>
+          <a:prstGeom prst="rect">
+            <a:avLst/>
+          </a:prstGeom>
+          <a:solidFill>
+            <a:srgbClr val="D05A1A"/>
+          </a:solidFill>
+          <a:ln>
+            <a:noFill/>
+          </a:ln>
+        </p:spPr>
+        <p:style>
+          <a:lnRef idx="1">
+            <a:schemeClr val="accent1"/>
+          </a:lnRef>
+          <a:fillRef idx="3">
+            <a:schemeClr val="accent1"/>
+          </a:fillRef>
+          <a:effectRef idx="2">
+            <a:schemeClr val="accent1"/>
+          </a:effectRef>
+          <a:fontRef idx="minor">
+            <a:schemeClr val="lt1"/>
+          </a:fontRef>
+        </p:style>
+        <p:txBody>
+          <a:bodyPr rtlCol="0" anchor="ctr"/>
+          <a:lstStyle/>
+          <a:p>
+            <a:pPr algn="ctr"/>
+          </a:p>
+        </p:txBody>
+      </p:sp>
+      <p:sp>
+        <p:nvSpPr>
+          <p:cNvPr id="53" name="TextBox 52"/>
+          <p:cNvSpPr txBox="1"/>
+          <p:nvPr/>
+        </p:nvSpPr>
+        <p:spPr>
+          <a:xfrm>
+            <a:off x="3456432" y="5769864"/>
+            <a:ext cx="2487168" cy="182880"/>
+          </a:xfrm>
+          <a:prstGeom prst="rect">
+            <a:avLst/>
+          </a:prstGeom>
+          <a:noFill/>
+        </p:spPr>
+        <p:txBody>
+          <a:bodyPr wrap="square">
+            <a:spAutoFit/>
+          </a:bodyPr>
+          <a:lstStyle/>
+          <a:p>
+            <a:pPr algn="l"/>
+            <a:r>
+              <a:rPr sz="1100" b="1">
+                <a:solidFill>
+                  <a:srgbClr val="3D4A55"/>
+                </a:solidFill>
+                <a:latin typeface="Calibri"/>
+              </a:rPr>
+              <a:t>KNORR</a:t>
+            </a:r>
+          </a:p>
+        </p:txBody>
+      </p:sp>
+      <p:sp>
+        <p:nvSpPr>
+          <p:cNvPr id="54" name="TextBox 53"/>
+          <p:cNvSpPr txBox="1"/>
+          <p:nvPr/>
+        </p:nvSpPr>
+        <p:spPr>
+          <a:xfrm>
+            <a:off x="3456432" y="5943600"/>
+            <a:ext cx="2487168" cy="237744"/>
+          </a:xfrm>
+          <a:prstGeom prst="rect">
+            <a:avLst/>
+          </a:prstGeom>
+          <a:noFill/>
+        </p:spPr>
+        <p:txBody>
+          <a:bodyPr wrap="square">
+            <a:spAutoFit/>
+          </a:bodyPr>
+          <a:lstStyle/>
+          <a:p>
+            <a:pPr algn="l"/>
+            <a:r>
+              <a:rPr sz="2000" b="1">
+                <a:solidFill>
+                  <a:srgbClr val="122A4A"/>
+                </a:solidFill>
+                <a:latin typeface="Calibri"/>
+              </a:rPr>
+              <a:t>R49.11</a:t>
+            </a:r>
+          </a:p>
+        </p:txBody>
+      </p:sp>
+      <p:sp>
+        <p:nvSpPr>
+          <p:cNvPr id="55" name="TextBox 54"/>
+          <p:cNvSpPr txBox="1"/>
+          <p:nvPr/>
+        </p:nvSpPr>
+        <p:spPr>
+          <a:xfrm>
+            <a:off x="3456432" y="6181344"/>
+            <a:ext cx="2487168" cy="182880"/>
+          </a:xfrm>
+          <a:prstGeom prst="rect">
+            <a:avLst/>
+          </a:prstGeom>
+          <a:noFill/>
+        </p:spPr>
+        <p:txBody>
+          <a:bodyPr wrap="square">
+            <a:spAutoFit/>
+          </a:bodyPr>
+          <a:lstStyle/>
+          <a:p>
+            <a:pPr algn="l"/>
+            <a:r>
+              <a:rPr sz="1200" b="0">
+                <a:solidFill>
+                  <a:srgbClr val="111111"/>
+                </a:solidFill>
+                <a:latin typeface="Calibri"/>
+              </a:rPr>
+              <a:t>Pasta Pots  ·  ~8× sachet</a:t>
+            </a:r>
+          </a:p>
+        </p:txBody>
+      </p:sp>
+      <p:sp>
+        <p:nvSpPr>
+          <p:cNvPr id="56" name="TextBox 55"/>
+          <p:cNvSpPr txBox="1"/>
+          <p:nvPr/>
+        </p:nvSpPr>
+        <p:spPr>
+          <a:xfrm>
+            <a:off x="6217920" y="4572000"/>
+            <a:ext cx="5577840" cy="292608"/>
           </a:xfrm>
           <a:prstGeom prst="rect">
             <a:avLst/>
@@ -7969,14 +8625,14 @@
       </p:sp>
       <p:graphicFrame>
         <p:nvGraphicFramePr>
-          <p:cNvPr id="37" name="Table 36"/>
+          <p:cNvPr id="57" name="Table 56"/>
           <p:cNvGraphicFramePr>
             <a:graphicFrameLocks noGrp="1"/>
           </p:cNvGraphicFramePr>
           <p:nvPr/>
         </p:nvGraphicFramePr>
         <p:xfrm>
-          <a:off x="6217920" y="4864608"/>
+          <a:off x="6217920" y="5047488"/>
           <a:ext cx="5623560" cy="1417320"/>
         </p:xfrm>
         <a:graphic>
@@ -8527,7 +9183,7 @@
         <p:spPr>
           <a:xfrm>
             <a:off x="347472" y="164592"/>
-            <a:ext cx="11338560" cy="420624"/>
+            <a:ext cx="9509760" cy="420624"/>
           </a:xfrm>
           <a:prstGeom prst="rect">
             <a:avLst/>
@@ -8542,7 +9198,7 @@
           <a:p>
             <a:pPr algn="l"/>
             <a:r>
-              <a:rPr sz="2600" b="1">
+              <a:rPr sz="2400" b="1">
                 <a:solidFill>
                   <a:srgbClr val="122A4A"/>
                 </a:solidFill>
@@ -8596,9 +9252,33 @@
           </a:p>
         </p:txBody>
       </p:sp>
-      <p:sp>
-        <p:nvSpPr>
-          <p:cNvPr id="7" name="Rectangle 6"/>
+      <p:pic>
+        <p:nvPicPr>
+          <p:cNvPr id="7" name="Picture 6" descr="smollan_logo_content.png"/>
+          <p:cNvPicPr>
+            <a:picLocks noChangeAspect="1"/>
+          </p:cNvPicPr>
+          <p:nvPr/>
+        </p:nvPicPr>
+        <p:blipFill>
+          <a:blip r:embed="rId2"/>
+          <a:stretch>
+            <a:fillRect/>
+          </a:stretch>
+        </p:blipFill>
+        <p:spPr>
+          <a:xfrm>
+            <a:off x="10104120" y="128016"/>
+            <a:ext cx="1783080" cy="384048"/>
+          </a:xfrm>
+          <a:prstGeom prst="rect">
+            <a:avLst/>
+          </a:prstGeom>
+        </p:spPr>
+      </p:pic>
+      <p:sp>
+        <p:nvSpPr>
+          <p:cNvPr id="8" name="Rectangle 7"/>
           <p:cNvSpPr/>
           <p:nvPr/>
         </p:nvSpPr>
@@ -8641,7 +9321,7 @@
       </p:sp>
       <p:sp>
         <p:nvSpPr>
-          <p:cNvPr id="8" name="TextBox 7"/>
+          <p:cNvPr id="9" name="TextBox 8"/>
           <p:cNvSpPr txBox="1"/>
           <p:nvPr/>
         </p:nvSpPr>
@@ -8676,7 +9356,7 @@
       </p:sp>
       <p:sp>
         <p:nvSpPr>
-          <p:cNvPr id="9" name="TextBox 8"/>
+          <p:cNvPr id="10" name="TextBox 9"/>
           <p:cNvSpPr txBox="1"/>
           <p:nvPr/>
         </p:nvSpPr>
@@ -8711,7 +9391,7 @@
       </p:sp>
       <p:sp>
         <p:nvSpPr>
-          <p:cNvPr id="10" name="Rectangle 9"/>
+          <p:cNvPr id="11" name="Rectangle 10"/>
           <p:cNvSpPr/>
           <p:nvPr/>
         </p:nvSpPr>
@@ -8756,7 +9436,7 @@
       </p:sp>
       <p:sp>
         <p:nvSpPr>
-          <p:cNvPr id="11" name="Rectangle 10"/>
+          <p:cNvPr id="12" name="Rectangle 11"/>
           <p:cNvSpPr/>
           <p:nvPr/>
         </p:nvSpPr>
@@ -8799,7 +9479,7 @@
       </p:sp>
       <p:sp>
         <p:nvSpPr>
-          <p:cNvPr id="12" name="TextBox 11"/>
+          <p:cNvPr id="13" name="TextBox 12"/>
           <p:cNvSpPr txBox="1"/>
           <p:nvPr/>
         </p:nvSpPr>
@@ -8834,7 +9514,7 @@
       </p:sp>
       <p:sp>
         <p:nvSpPr>
-          <p:cNvPr id="13" name="TextBox 12"/>
+          <p:cNvPr id="14" name="TextBox 13"/>
           <p:cNvSpPr txBox="1"/>
           <p:nvPr/>
         </p:nvSpPr>
@@ -8869,7 +9549,7 @@
       </p:sp>
       <p:sp>
         <p:nvSpPr>
-          <p:cNvPr id="14" name="TextBox 13"/>
+          <p:cNvPr id="15" name="TextBox 14"/>
           <p:cNvSpPr txBox="1"/>
           <p:nvPr/>
         </p:nvSpPr>
@@ -8904,7 +9584,7 @@
       </p:sp>
       <p:sp>
         <p:nvSpPr>
-          <p:cNvPr id="15" name="Rectangle 14"/>
+          <p:cNvPr id="16" name="Rectangle 15"/>
           <p:cNvSpPr/>
           <p:nvPr/>
         </p:nvSpPr>
@@ -8949,7 +9629,7 @@
       </p:sp>
       <p:sp>
         <p:nvSpPr>
-          <p:cNvPr id="16" name="Rectangle 15"/>
+          <p:cNvPr id="17" name="Rectangle 16"/>
           <p:cNvSpPr/>
           <p:nvPr/>
         </p:nvSpPr>
@@ -8992,7 +9672,7 @@
       </p:sp>
       <p:sp>
         <p:nvSpPr>
-          <p:cNvPr id="17" name="TextBox 16"/>
+          <p:cNvPr id="18" name="TextBox 17"/>
           <p:cNvSpPr txBox="1"/>
           <p:nvPr/>
         </p:nvSpPr>
@@ -9027,7 +9707,7 @@
       </p:sp>
       <p:sp>
         <p:nvSpPr>
-          <p:cNvPr id="18" name="TextBox 17"/>
+          <p:cNvPr id="19" name="TextBox 18"/>
           <p:cNvSpPr txBox="1"/>
           <p:nvPr/>
         </p:nvSpPr>
@@ -9062,7 +9742,7 @@
       </p:sp>
       <p:sp>
         <p:nvSpPr>
-          <p:cNvPr id="19" name="TextBox 18"/>
+          <p:cNvPr id="20" name="TextBox 19"/>
           <p:cNvSpPr txBox="1"/>
           <p:nvPr/>
         </p:nvSpPr>
@@ -9097,7 +9777,7 @@
       </p:sp>
       <p:sp>
         <p:nvSpPr>
-          <p:cNvPr id="20" name="Rectangle 19"/>
+          <p:cNvPr id="21" name="Rectangle 20"/>
           <p:cNvSpPr/>
           <p:nvPr/>
         </p:nvSpPr>
@@ -9142,7 +9822,7 @@
       </p:sp>
       <p:sp>
         <p:nvSpPr>
-          <p:cNvPr id="21" name="Rectangle 20"/>
+          <p:cNvPr id="22" name="Rectangle 21"/>
           <p:cNvSpPr/>
           <p:nvPr/>
         </p:nvSpPr>
@@ -9185,7 +9865,7 @@
       </p:sp>
       <p:sp>
         <p:nvSpPr>
-          <p:cNvPr id="22" name="TextBox 21"/>
+          <p:cNvPr id="23" name="TextBox 22"/>
           <p:cNvSpPr txBox="1"/>
           <p:nvPr/>
         </p:nvSpPr>
@@ -9220,7 +9900,7 @@
       </p:sp>
       <p:sp>
         <p:nvSpPr>
-          <p:cNvPr id="23" name="TextBox 22"/>
+          <p:cNvPr id="24" name="TextBox 23"/>
           <p:cNvSpPr txBox="1"/>
           <p:nvPr/>
         </p:nvSpPr>
@@ -9255,7 +9935,7 @@
       </p:sp>
       <p:sp>
         <p:nvSpPr>
-          <p:cNvPr id="24" name="TextBox 23"/>
+          <p:cNvPr id="25" name="TextBox 24"/>
           <p:cNvSpPr txBox="1"/>
           <p:nvPr/>
         </p:nvSpPr>
@@ -9290,7 +9970,7 @@
       </p:sp>
       <p:sp>
         <p:nvSpPr>
-          <p:cNvPr id="25" name="Rectangle 24"/>
+          <p:cNvPr id="26" name="Rectangle 25"/>
           <p:cNvSpPr/>
           <p:nvPr/>
         </p:nvSpPr>
@@ -9335,7 +10015,7 @@
       </p:sp>
       <p:sp>
         <p:nvSpPr>
-          <p:cNvPr id="26" name="Rectangle 25"/>
+          <p:cNvPr id="27" name="Rectangle 26"/>
           <p:cNvSpPr/>
           <p:nvPr/>
         </p:nvSpPr>
@@ -9378,7 +10058,7 @@
       </p:sp>
       <p:sp>
         <p:nvSpPr>
-          <p:cNvPr id="27" name="TextBox 26"/>
+          <p:cNvPr id="28" name="TextBox 27"/>
           <p:cNvSpPr txBox="1"/>
           <p:nvPr/>
         </p:nvSpPr>
@@ -9413,7 +10093,7 @@
       </p:sp>
       <p:sp>
         <p:nvSpPr>
-          <p:cNvPr id="28" name="TextBox 27"/>
+          <p:cNvPr id="29" name="TextBox 28"/>
           <p:cNvSpPr txBox="1"/>
           <p:nvPr/>
         </p:nvSpPr>
@@ -9448,7 +10128,7 @@
       </p:sp>
       <p:sp>
         <p:nvSpPr>
-          <p:cNvPr id="29" name="TextBox 28"/>
+          <p:cNvPr id="30" name="TextBox 29"/>
           <p:cNvSpPr txBox="1"/>
           <p:nvPr/>
         </p:nvSpPr>

</xml_diff>

<commit_message>
Restore a readable noodles price ladder and stop stretching charts
The four price cards made slide 3 worse. Give the price ladder its own
slide with a full-height bar chart, place pictures by width only so
labels keep their aspect ratio, and split players vs price so six bars
are no longer forced into a short strip.

Co-authored-by: Bongumusa Joseph Hlongwane <Joemusa@users.noreply.github.com>
</commit_message>
<xml_diff>
--- a/output/Unilever_Pasta_Noodles_Jun2026.pptx
+++ b/output/Unilever_Pasta_Noodles_Jun2026.pptx
@@ -10,6 +10,7 @@
     <p:sldId id="258" r:id="rId9"/>
     <p:sldId id="259" r:id="rId10"/>
     <p:sldId id="260" r:id="rId11"/>
+    <p:sldId id="261" r:id="rId12"/>
   </p:sldIdLst>
   <p:sldSz cx="12191695" cy="6858000" type="screen4x3"/>
   <p:notesSz cx="6858000" cy="9144000"/>
@@ -3672,7 +3673,7 @@
                 </a:solidFill>
                 <a:latin typeface="Calibri"/>
               </a:rPr>
-              <a:t>2 / 5</a:t>
+              <a:t>2 / 6</a:t>
             </a:r>
           </a:p>
         </p:txBody>
@@ -4458,7 +4459,7 @@
         <p:spPr>
           <a:xfrm>
             <a:off x="347472" y="1938528"/>
-            <a:ext cx="5760720" cy="292608"/>
+            <a:ext cx="5760720" cy="256032"/>
           </a:xfrm>
           <a:prstGeom prst="rect">
             <a:avLst/>
@@ -4500,8 +4501,8 @@
         </p:blipFill>
         <p:spPr>
           <a:xfrm>
-            <a:off x="256032" y="2359152"/>
-            <a:ext cx="5852160" cy="2527069"/>
+            <a:off x="256032" y="2212848"/>
+            <a:ext cx="5852160" cy="2895600"/>
           </a:xfrm>
           <a:prstGeom prst="rect">
             <a:avLst/>
@@ -4517,7 +4518,7 @@
         <p:spPr>
           <a:xfrm>
             <a:off x="6309360" y="1938528"/>
-            <a:ext cx="5486400" cy="292608"/>
+            <a:ext cx="5486400" cy="256032"/>
           </a:xfrm>
           <a:prstGeom prst="rect">
             <a:avLst/>
@@ -4552,8 +4553,8 @@
           <p:nvPr/>
         </p:nvGraphicFramePr>
         <p:xfrm>
-          <a:off x="6309360" y="2359152"/>
-          <a:ext cx="5532120" cy="2880360"/>
+          <a:off x="6309360" y="2212848"/>
+          <a:ext cx="5532120" cy="3063240"/>
         </p:xfrm>
         <a:graphic>
           <a:graphicData uri="http://schemas.openxmlformats.org/drawingml/2006/table">
@@ -4568,7 +4569,7 @@
                 <a:gridCol w="1005840"/>
                 <a:gridCol w="1005840"/>
               </a:tblGrid>
-              <a:tr h="360045">
+              <a:tr h="382905">
                 <a:tc>
                   <a:txBody>
                     <a:bodyPr/>
@@ -4685,7 +4686,7 @@
                   </a:tcPr>
                 </a:tc>
               </a:tr>
-              <a:tr h="360045">
+              <a:tr h="382905">
                 <a:tc>
                   <a:txBody>
                     <a:bodyPr/>
@@ -4802,7 +4803,7 @@
                   </a:tcPr>
                 </a:tc>
               </a:tr>
-              <a:tr h="360045">
+              <a:tr h="382905">
                 <a:tc>
                   <a:txBody>
                     <a:bodyPr/>
@@ -4919,7 +4920,7 @@
                   </a:tcPr>
                 </a:tc>
               </a:tr>
-              <a:tr h="360045">
+              <a:tr h="382905">
                 <a:tc>
                   <a:txBody>
                     <a:bodyPr/>
@@ -5036,7 +5037,7 @@
                   </a:tcPr>
                 </a:tc>
               </a:tr>
-              <a:tr h="360045">
+              <a:tr h="382905">
                 <a:tc>
                   <a:txBody>
                     <a:bodyPr/>
@@ -5153,7 +5154,7 @@
                   </a:tcPr>
                 </a:tc>
               </a:tr>
-              <a:tr h="360045">
+              <a:tr h="382905">
                 <a:tc>
                   <a:txBody>
                     <a:bodyPr/>
@@ -5270,7 +5271,7 @@
                   </a:tcPr>
                 </a:tc>
               </a:tr>
-              <a:tr h="360045">
+              <a:tr h="382905">
                 <a:tc>
                   <a:txBody>
                     <a:bodyPr/>
@@ -5387,7 +5388,7 @@
                   </a:tcPr>
                 </a:tc>
               </a:tr>
-              <a:tr h="360045">
+              <a:tr h="382905">
                 <a:tc>
                   <a:txBody>
                     <a:bodyPr/>
@@ -5516,8 +5517,8 @@
         </p:nvSpPr>
         <p:spPr>
           <a:xfrm>
-            <a:off x="347472" y="5074920"/>
-            <a:ext cx="11475720" cy="1325880"/>
+            <a:off x="347472" y="5577840"/>
+            <a:ext cx="11475720" cy="868680"/>
           </a:xfrm>
           <a:prstGeom prst="rect">
             <a:avLst/>
@@ -5720,7 +5721,7 @@
                 </a:solidFill>
                 <a:latin typeface="Calibri"/>
               </a:rPr>
-              <a:t>Noodles: players, winners, price — and where Unilever sits</a:t>
+              <a:t>Noodles: who is winning and losing</a:t>
             </a:r>
           </a:p>
         </p:txBody>
@@ -5900,7 +5901,7 @@
                 </a:solidFill>
                 <a:latin typeface="Calibri"/>
               </a:rPr>
-              <a:t>3 / 5</a:t>
+              <a:t>3 / 6</a:t>
             </a:r>
           </a:p>
         </p:txBody>
@@ -6686,7 +6687,7 @@
         <p:spPr>
           <a:xfrm>
             <a:off x="347472" y="1792224"/>
-            <a:ext cx="5760720" cy="292608"/>
+            <a:ext cx="5760720" cy="237744"/>
           </a:xfrm>
           <a:prstGeom prst="rect">
             <a:avLst/>
@@ -6707,7 +6708,7 @@
                 </a:solidFill>
                 <a:latin typeface="Calibri"/>
               </a:rPr>
-              <a:t>Who is winning and losing</a:t>
+              <a:t>12-month Noodles value share</a:t>
             </a:r>
           </a:p>
         </p:txBody>
@@ -6728,8 +6729,8 @@
         </p:blipFill>
         <p:spPr>
           <a:xfrm>
-            <a:off x="201168" y="2395728"/>
-            <a:ext cx="5852160" cy="1995055"/>
+            <a:off x="201168" y="2048256"/>
+            <a:ext cx="5943600" cy="3838575"/>
           </a:xfrm>
           <a:prstGeom prst="rect">
             <a:avLst/>
@@ -6745,7 +6746,7 @@
         <p:spPr>
           <a:xfrm>
             <a:off x="6217920" y="1792224"/>
-            <a:ext cx="5577840" cy="292608"/>
+            <a:ext cx="5577840" cy="237744"/>
           </a:xfrm>
           <a:prstGeom prst="rect">
             <a:avLst/>
@@ -6780,8 +6781,8 @@
           <p:nvPr/>
         </p:nvGraphicFramePr>
         <p:xfrm>
-          <a:off x="6217920" y="2395728"/>
-          <a:ext cx="5623560" cy="1874519"/>
+          <a:off x="6217920" y="2048256"/>
+          <a:ext cx="5623560" cy="4160520"/>
         </p:xfrm>
         <a:graphic>
           <a:graphicData uri="http://schemas.openxmlformats.org/drawingml/2006/table">
@@ -6797,7 +6798,7 @@
                 <a:gridCol w="960120"/>
                 <a:gridCol w="1005840"/>
               </a:tblGrid>
-              <a:tr h="267788">
+              <a:tr h="594360">
                 <a:tc>
                   <a:txBody>
                     <a:bodyPr/>
@@ -6937,7 +6938,7 @@
                   </a:tcPr>
                 </a:tc>
               </a:tr>
-              <a:tr h="267788">
+              <a:tr h="594360">
                 <a:tc>
                   <a:txBody>
                     <a:bodyPr/>
@@ -7077,7 +7078,7 @@
                   </a:tcPr>
                 </a:tc>
               </a:tr>
-              <a:tr h="267788">
+              <a:tr h="594360">
                 <a:tc>
                   <a:txBody>
                     <a:bodyPr/>
@@ -7217,7 +7218,7 @@
                   </a:tcPr>
                 </a:tc>
               </a:tr>
-              <a:tr h="267788">
+              <a:tr h="594360">
                 <a:tc>
                   <a:txBody>
                     <a:bodyPr/>
@@ -7357,7 +7358,7 @@
                   </a:tcPr>
                 </a:tc>
               </a:tr>
-              <a:tr h="267788">
+              <a:tr h="594360">
                 <a:tc>
                   <a:txBody>
                     <a:bodyPr/>
@@ -7497,7 +7498,7 @@
                   </a:tcPr>
                 </a:tc>
               </a:tr>
-              <a:tr h="267788">
+              <a:tr h="594360">
                 <a:tc>
                   <a:txBody>
                     <a:bodyPr/>
@@ -7637,7 +7638,7 @@
                   </a:tcPr>
                 </a:tc>
               </a:tr>
-              <a:tr h="267791">
+              <a:tr h="594360">
                 <a:tc>
                   <a:txBody>
                     <a:bodyPr/>
@@ -7781,16 +7782,378 @@
           </a:graphicData>
         </a:graphic>
       </p:graphicFrame>
-      <p:sp>
-        <p:nvSpPr>
-          <p:cNvPr id="35" name="TextBox 34"/>
+    </p:spTree>
+  </p:cSld>
+  <p:clrMapOvr>
+    <a:masterClrMapping/>
+  </p:clrMapOvr>
+</p:sld>
+</file>
+
+<file path=ppt/slides/slide4.xml><?xml version="1.0" encoding="utf-8"?>
+<p:sld xmlns:a="http://schemas.openxmlformats.org/drawingml/2006/main" xmlns:p="http://schemas.openxmlformats.org/presentationml/2006/main" xmlns:r="http://schemas.openxmlformats.org/officeDocument/2006/relationships">
+  <p:cSld>
+    <p:spTree>
+      <p:nvGrpSpPr>
+        <p:cNvPr id="1" name=""/>
+        <p:cNvGrpSpPr/>
+        <p:nvPr/>
+      </p:nvGrpSpPr>
+      <p:grpSpPr/>
+      <p:sp>
+        <p:nvSpPr>
+          <p:cNvPr id="2" name="Rectangle 1"/>
+          <p:cNvSpPr/>
+          <p:nvPr/>
+        </p:nvSpPr>
+        <p:spPr>
+          <a:xfrm>
+            <a:off x="0" y="0"/>
+            <a:ext cx="12191695" cy="6858000"/>
+          </a:xfrm>
+          <a:prstGeom prst="rect">
+            <a:avLst/>
+          </a:prstGeom>
+          <a:solidFill>
+            <a:srgbClr val="FFFFFF"/>
+          </a:solidFill>
+          <a:ln>
+            <a:noFill/>
+          </a:ln>
+        </p:spPr>
+        <p:style>
+          <a:lnRef idx="1">
+            <a:schemeClr val="accent1"/>
+          </a:lnRef>
+          <a:fillRef idx="3">
+            <a:schemeClr val="accent1"/>
+          </a:fillRef>
+          <a:effectRef idx="2">
+            <a:schemeClr val="accent1"/>
+          </a:effectRef>
+          <a:fontRef idx="minor">
+            <a:schemeClr val="lt1"/>
+          </a:fontRef>
+        </p:style>
+        <p:txBody>
+          <a:bodyPr rtlCol="0" anchor="ctr"/>
+          <a:lstStyle/>
+          <a:p>
+            <a:pPr algn="ctr"/>
+          </a:p>
+        </p:txBody>
+      </p:sp>
+      <p:sp>
+        <p:nvSpPr>
+          <p:cNvPr id="3" name="Rectangle 2"/>
+          <p:cNvSpPr/>
+          <p:nvPr/>
+        </p:nvSpPr>
+        <p:spPr>
+          <a:xfrm>
+            <a:off x="0" y="0"/>
+            <a:ext cx="109728" cy="6858000"/>
+          </a:xfrm>
+          <a:prstGeom prst="rect">
+            <a:avLst/>
+          </a:prstGeom>
+          <a:solidFill>
+            <a:srgbClr val="122A4A"/>
+          </a:solidFill>
+          <a:ln>
+            <a:noFill/>
+          </a:ln>
+        </p:spPr>
+        <p:style>
+          <a:lnRef idx="1">
+            <a:schemeClr val="accent1"/>
+          </a:lnRef>
+          <a:fillRef idx="3">
+            <a:schemeClr val="accent1"/>
+          </a:fillRef>
+          <a:effectRef idx="2">
+            <a:schemeClr val="accent1"/>
+          </a:effectRef>
+          <a:fontRef idx="minor">
+            <a:schemeClr val="lt1"/>
+          </a:fontRef>
+        </p:style>
+        <p:txBody>
+          <a:bodyPr rtlCol="0" anchor="ctr"/>
+          <a:lstStyle/>
+          <a:p>
+            <a:pPr algn="ctr"/>
+          </a:p>
+        </p:txBody>
+      </p:sp>
+      <p:sp>
+        <p:nvSpPr>
+          <p:cNvPr id="4" name="Rectangle 3"/>
+          <p:cNvSpPr/>
+          <p:nvPr/>
+        </p:nvSpPr>
+        <p:spPr>
+          <a:xfrm>
+            <a:off x="0" y="0"/>
+            <a:ext cx="12191695" cy="73152"/>
+          </a:xfrm>
+          <a:prstGeom prst="rect">
+            <a:avLst/>
+          </a:prstGeom>
+          <a:solidFill>
+            <a:srgbClr val="122A4A"/>
+          </a:solidFill>
+          <a:ln>
+            <a:noFill/>
+          </a:ln>
+        </p:spPr>
+        <p:style>
+          <a:lnRef idx="1">
+            <a:schemeClr val="accent1"/>
+          </a:lnRef>
+          <a:fillRef idx="3">
+            <a:schemeClr val="accent1"/>
+          </a:fillRef>
+          <a:effectRef idx="2">
+            <a:schemeClr val="accent1"/>
+          </a:effectRef>
+          <a:fontRef idx="minor">
+            <a:schemeClr val="lt1"/>
+          </a:fontRef>
+        </p:style>
+        <p:txBody>
+          <a:bodyPr rtlCol="0" anchor="ctr"/>
+          <a:lstStyle/>
+          <a:p>
+            <a:pPr algn="ctr"/>
+          </a:p>
+        </p:txBody>
+      </p:sp>
+      <p:sp>
+        <p:nvSpPr>
+          <p:cNvPr id="5" name="TextBox 4"/>
           <p:cNvSpPr txBox="1"/>
           <p:nvPr/>
         </p:nvSpPr>
         <p:spPr>
           <a:xfrm>
-            <a:off x="347472" y="4572000"/>
-            <a:ext cx="5760720" cy="292608"/>
+            <a:off x="347472" y="164592"/>
+            <a:ext cx="9509760" cy="420624"/>
+          </a:xfrm>
+          <a:prstGeom prst="rect">
+            <a:avLst/>
+          </a:prstGeom>
+          <a:noFill/>
+        </p:spPr>
+        <p:txBody>
+          <a:bodyPr wrap="square">
+            <a:spAutoFit/>
+          </a:bodyPr>
+          <a:lstStyle/>
+          <a:p>
+            <a:pPr algn="l"/>
+            <a:r>
+              <a:rPr sz="2400" b="1">
+                <a:solidFill>
+                  <a:srgbClr val="122A4A"/>
+                </a:solidFill>
+                <a:latin typeface="Calibri"/>
+              </a:rPr>
+              <a:t>Noodles price point — and where Unilever sits</a:t>
+            </a:r>
+          </a:p>
+        </p:txBody>
+      </p:sp>
+      <p:sp>
+        <p:nvSpPr>
+          <p:cNvPr id="6" name="Rectangle 5"/>
+          <p:cNvSpPr/>
+          <p:nvPr/>
+        </p:nvSpPr>
+        <p:spPr>
+          <a:xfrm>
+            <a:off x="347472" y="603504"/>
+            <a:ext cx="2011680" cy="54864"/>
+          </a:xfrm>
+          <a:prstGeom prst="rect">
+            <a:avLst/>
+          </a:prstGeom>
+          <a:solidFill>
+            <a:srgbClr val="D05A1A"/>
+          </a:solidFill>
+          <a:ln>
+            <a:noFill/>
+          </a:ln>
+        </p:spPr>
+        <p:style>
+          <a:lnRef idx="1">
+            <a:schemeClr val="accent1"/>
+          </a:lnRef>
+          <a:fillRef idx="3">
+            <a:schemeClr val="accent1"/>
+          </a:fillRef>
+          <a:effectRef idx="2">
+            <a:schemeClr val="accent1"/>
+          </a:effectRef>
+          <a:fontRef idx="minor">
+            <a:schemeClr val="lt1"/>
+          </a:fontRef>
+        </p:style>
+        <p:txBody>
+          <a:bodyPr rtlCol="0" anchor="ctr"/>
+          <a:lstStyle/>
+          <a:p>
+            <a:pPr algn="ctr"/>
+          </a:p>
+        </p:txBody>
+      </p:sp>
+      <p:pic>
+        <p:nvPicPr>
+          <p:cNvPr id="7" name="Picture 6" descr="smollan_logo_content.png"/>
+          <p:cNvPicPr>
+            <a:picLocks noChangeAspect="1"/>
+          </p:cNvPicPr>
+          <p:nvPr/>
+        </p:nvPicPr>
+        <p:blipFill>
+          <a:blip r:embed="rId2"/>
+          <a:stretch>
+            <a:fillRect/>
+          </a:stretch>
+        </p:blipFill>
+        <p:spPr>
+          <a:xfrm>
+            <a:off x="10104120" y="128016"/>
+            <a:ext cx="1783080" cy="384048"/>
+          </a:xfrm>
+          <a:prstGeom prst="rect">
+            <a:avLst/>
+          </a:prstGeom>
+        </p:spPr>
+      </p:pic>
+      <p:sp>
+        <p:nvSpPr>
+          <p:cNvPr id="8" name="Rectangle 7"/>
+          <p:cNvSpPr/>
+          <p:nvPr/>
+        </p:nvSpPr>
+        <p:spPr>
+          <a:xfrm>
+            <a:off x="0" y="6565392"/>
+            <a:ext cx="12191695" cy="292608"/>
+          </a:xfrm>
+          <a:prstGeom prst="rect">
+            <a:avLst/>
+          </a:prstGeom>
+          <a:solidFill>
+            <a:srgbClr val="F3F5F7"/>
+          </a:solidFill>
+          <a:ln>
+            <a:noFill/>
+          </a:ln>
+        </p:spPr>
+        <p:style>
+          <a:lnRef idx="1">
+            <a:schemeClr val="accent1"/>
+          </a:lnRef>
+          <a:fillRef idx="3">
+            <a:schemeClr val="accent1"/>
+          </a:fillRef>
+          <a:effectRef idx="2">
+            <a:schemeClr val="accent1"/>
+          </a:effectRef>
+          <a:fontRef idx="minor">
+            <a:schemeClr val="lt1"/>
+          </a:fontRef>
+        </p:style>
+        <p:txBody>
+          <a:bodyPr rtlCol="0" anchor="ctr"/>
+          <a:lstStyle/>
+          <a:p>
+            <a:pPr algn="ctr"/>
+          </a:p>
+        </p:txBody>
+      </p:sp>
+      <p:sp>
+        <p:nvSpPr>
+          <p:cNvPr id="9" name="TextBox 8"/>
+          <p:cNvSpPr txBox="1"/>
+          <p:nvPr/>
+        </p:nvSpPr>
+        <p:spPr>
+          <a:xfrm>
+            <a:off x="347472" y="6601968"/>
+            <a:ext cx="8412480" cy="201168"/>
+          </a:xfrm>
+          <a:prstGeom prst="rect">
+            <a:avLst/>
+          </a:prstGeom>
+          <a:noFill/>
+        </p:spPr>
+        <p:txBody>
+          <a:bodyPr wrap="square">
+            <a:spAutoFit/>
+          </a:bodyPr>
+          <a:lstStyle/>
+          <a:p>
+            <a:pPr algn="l"/>
+            <a:r>
+              <a:rPr sz="1100" b="0">
+                <a:solidFill>
+                  <a:srgbClr val="3D4A55"/>
+                </a:solidFill>
+                <a:latin typeface="Calibri"/>
+              </a:rPr>
+              <a:t>South Africa Pasta  ·  12 months Jul 25–Jun 26 vs YA  ·  latest month Jun 26  ·  price = value ÷ volume</a:t>
+            </a:r>
+          </a:p>
+        </p:txBody>
+      </p:sp>
+      <p:sp>
+        <p:nvSpPr>
+          <p:cNvPr id="10" name="TextBox 9"/>
+          <p:cNvSpPr txBox="1"/>
+          <p:nvPr/>
+        </p:nvSpPr>
+        <p:spPr>
+          <a:xfrm>
+            <a:off x="10424160" y="6601968"/>
+            <a:ext cx="1417320" cy="201168"/>
+          </a:xfrm>
+          <a:prstGeom prst="rect">
+            <a:avLst/>
+          </a:prstGeom>
+          <a:noFill/>
+        </p:spPr>
+        <p:txBody>
+          <a:bodyPr wrap="square">
+            <a:spAutoFit/>
+          </a:bodyPr>
+          <a:lstStyle/>
+          <a:p>
+            <a:pPr algn="r"/>
+            <a:r>
+              <a:rPr sz="1100" b="1">
+                <a:solidFill>
+                  <a:srgbClr val="122A4A"/>
+                </a:solidFill>
+                <a:latin typeface="Calibri"/>
+              </a:rPr>
+              <a:t>4 / 6</a:t>
+            </a:r>
+          </a:p>
+        </p:txBody>
+      </p:sp>
+      <p:sp>
+        <p:nvSpPr>
+          <p:cNvPr id="11" name="TextBox 10"/>
+          <p:cNvSpPr txBox="1"/>
+          <p:nvPr/>
+        </p:nvSpPr>
+        <p:spPr>
+          <a:xfrm>
+            <a:off x="347472" y="786384"/>
+            <a:ext cx="5852160" cy="256032"/>
           </a:xfrm>
           <a:prstGeom prst="rect">
             <a:avLst/>
@@ -7811,21 +8174,115 @@
                 </a:solidFill>
                 <a:latin typeface="Calibri"/>
               </a:rPr>
-              <a:t>Price ladder (typical unit)</a:t>
-            </a:r>
-          </a:p>
-        </p:txBody>
-      </p:sp>
-      <p:sp>
-        <p:nvSpPr>
-          <p:cNvPr id="36" name="Rectangle 35"/>
+              <a:t>Typical unit pack price</a:t>
+            </a:r>
+          </a:p>
+        </p:txBody>
+      </p:sp>
+      <p:pic>
+        <p:nvPicPr>
+          <p:cNvPr id="12" name="Picture 11" descr="data_price.png"/>
+          <p:cNvPicPr>
+            <a:picLocks noChangeAspect="1"/>
+          </p:cNvPicPr>
+          <p:nvPr/>
+        </p:nvPicPr>
+        <p:blipFill>
+          <a:blip r:embed="rId3"/>
+          <a:stretch>
+            <a:fillRect/>
+          </a:stretch>
+        </p:blipFill>
+        <p:spPr>
+          <a:xfrm>
+            <a:off x="201168" y="1060704"/>
+            <a:ext cx="5989320" cy="3868102"/>
+          </a:xfrm>
+          <a:prstGeom prst="rect">
+            <a:avLst/>
+          </a:prstGeom>
+        </p:spPr>
+      </p:pic>
+      <p:sp>
+        <p:nvSpPr>
+          <p:cNvPr id="13" name="TextBox 12"/>
+          <p:cNvSpPr txBox="1"/>
+          <p:nvPr/>
+        </p:nvSpPr>
+        <p:spPr>
+          <a:xfrm>
+            <a:off x="347472" y="5047488"/>
+            <a:ext cx="5852160" cy="502920"/>
+          </a:xfrm>
+          <a:prstGeom prst="rect">
+            <a:avLst/>
+          </a:prstGeom>
+          <a:noFill/>
+        </p:spPr>
+        <p:txBody>
+          <a:bodyPr wrap="square">
+            <a:spAutoFit/>
+          </a:bodyPr>
+          <a:lstStyle/>
+          <a:p>
+            <a:pPr algn="l"/>
+            <a:r>
+              <a:rPr sz="1300" b="0">
+                <a:solidFill>
+                  <a:srgbClr val="111111"/>
+                </a:solidFill>
+                <a:latin typeface="Calibri"/>
+              </a:rPr>
+              <a:t>Typical unit = volume-weighted R/kg × pack size. Sachets sit at R5.88–R7.90. Knorr is ~8× that.</a:t>
+            </a:r>
+          </a:p>
+        </p:txBody>
+      </p:sp>
+      <p:sp>
+        <p:nvSpPr>
+          <p:cNvPr id="14" name="TextBox 13"/>
+          <p:cNvSpPr txBox="1"/>
+          <p:nvPr/>
+        </p:nvSpPr>
+        <p:spPr>
+          <a:xfrm>
+            <a:off x="6309360" y="786384"/>
+            <a:ext cx="5532120" cy="256032"/>
+          </a:xfrm>
+          <a:prstGeom prst="rect">
+            <a:avLst/>
+          </a:prstGeom>
+          <a:noFill/>
+        </p:spPr>
+        <p:txBody>
+          <a:bodyPr wrap="square">
+            <a:spAutoFit/>
+          </a:bodyPr>
+          <a:lstStyle/>
+          <a:p>
+            <a:pPr algn="l"/>
+            <a:r>
+              <a:rPr sz="1600" b="1">
+                <a:solidFill>
+                  <a:srgbClr val="122A4A"/>
+                </a:solidFill>
+                <a:latin typeface="Calibri"/>
+              </a:rPr>
+              <a:t>Unilever SKUs — June 2026 only</a:t>
+            </a:r>
+          </a:p>
+        </p:txBody>
+      </p:sp>
+      <p:sp>
+        <p:nvSpPr>
+          <p:cNvPr id="15" name="Rectangle 14"/>
           <p:cNvSpPr/>
           <p:nvPr/>
         </p:nvSpPr>
         <p:spPr>
           <a:xfrm>
-            <a:off x="347472" y="4974336"/>
-            <a:ext cx="2788920" cy="676656"/>
+            <a:off x="6309360" y="1097280"/>
+            <a:ext cx="5532120" cy="1417320"/>
           </a:xfrm>
           <a:prstGeom prst="rect">
             <a:avLst/>
@@ -7863,593 +8320,14 @@
       </p:sp>
       <p:sp>
         <p:nvSpPr>
-          <p:cNvPr id="37" name="Rectangle 36"/>
+          <p:cNvPr id="16" name="Rectangle 15"/>
           <p:cNvSpPr/>
           <p:nvPr/>
         </p:nvSpPr>
         <p:spPr>
           <a:xfrm>
-            <a:off x="347472" y="4974336"/>
-            <a:ext cx="82296" cy="676656"/>
-          </a:xfrm>
-          <a:prstGeom prst="rect">
-            <a:avLst/>
-          </a:prstGeom>
-          <a:solidFill>
-            <a:srgbClr val="1F5FA8"/>
-          </a:solidFill>
-          <a:ln>
-            <a:noFill/>
-          </a:ln>
-        </p:spPr>
-        <p:style>
-          <a:lnRef idx="1">
-            <a:schemeClr val="accent1"/>
-          </a:lnRef>
-          <a:fillRef idx="3">
-            <a:schemeClr val="accent1"/>
-          </a:fillRef>
-          <a:effectRef idx="2">
-            <a:schemeClr val="accent1"/>
-          </a:effectRef>
-          <a:fontRef idx="minor">
-            <a:schemeClr val="lt1"/>
-          </a:fontRef>
-        </p:style>
-        <p:txBody>
-          <a:bodyPr rtlCol="0" anchor="ctr"/>
-          <a:lstStyle/>
-          <a:p>
-            <a:pPr algn="ctr"/>
-          </a:p>
-        </p:txBody>
-      </p:sp>
-      <p:sp>
-        <p:nvSpPr>
-          <p:cNvPr id="38" name="TextBox 37"/>
-          <p:cNvSpPr txBox="1"/>
-          <p:nvPr/>
-        </p:nvSpPr>
-        <p:spPr>
-          <a:xfrm>
-            <a:off x="530352" y="5020056"/>
-            <a:ext cx="2487168" cy="182880"/>
-          </a:xfrm>
-          <a:prstGeom prst="rect">
-            <a:avLst/>
-          </a:prstGeom>
-          <a:noFill/>
-        </p:spPr>
-        <p:txBody>
-          <a:bodyPr wrap="square">
-            <a:spAutoFit/>
-          </a:bodyPr>
-          <a:lstStyle/>
-          <a:p>
-            <a:pPr algn="l"/>
-            <a:r>
-              <a:rPr sz="1100" b="1">
-                <a:solidFill>
-                  <a:srgbClr val="3D4A55"/>
-                </a:solidFill>
-                <a:latin typeface="Calibri"/>
-              </a:rPr>
-              <a:t>ROKA</a:t>
-            </a:r>
-          </a:p>
-        </p:txBody>
-      </p:sp>
-      <p:sp>
-        <p:nvSpPr>
-          <p:cNvPr id="39" name="TextBox 38"/>
-          <p:cNvSpPr txBox="1"/>
-          <p:nvPr/>
-        </p:nvSpPr>
-        <p:spPr>
-          <a:xfrm>
-            <a:off x="530352" y="5193792"/>
-            <a:ext cx="2487168" cy="237744"/>
-          </a:xfrm>
-          <a:prstGeom prst="rect">
-            <a:avLst/>
-          </a:prstGeom>
-          <a:noFill/>
-        </p:spPr>
-        <p:txBody>
-          <a:bodyPr wrap="square">
-            <a:spAutoFit/>
-          </a:bodyPr>
-          <a:lstStyle/>
-          <a:p>
-            <a:pPr algn="l"/>
-            <a:r>
-              <a:rPr sz="2000" b="1">
-                <a:solidFill>
-                  <a:srgbClr val="122A4A"/>
-                </a:solidFill>
-                <a:latin typeface="Calibri"/>
-              </a:rPr>
-              <a:t>R5.88</a:t>
-            </a:r>
-          </a:p>
-        </p:txBody>
-      </p:sp>
-      <p:sp>
-        <p:nvSpPr>
-          <p:cNvPr id="40" name="TextBox 39"/>
-          <p:cNvSpPr txBox="1"/>
-          <p:nvPr/>
-        </p:nvSpPr>
-        <p:spPr>
-          <a:xfrm>
-            <a:off x="530352" y="5431536"/>
-            <a:ext cx="2487168" cy="182880"/>
-          </a:xfrm>
-          <a:prstGeom prst="rect">
-            <a:avLst/>
-          </a:prstGeom>
-          <a:noFill/>
-        </p:spPr>
-        <p:txBody>
-          <a:bodyPr wrap="square">
-            <a:spAutoFit/>
-          </a:bodyPr>
-          <a:lstStyle/>
-          <a:p>
-            <a:pPr algn="l"/>
-            <a:r>
-              <a:rPr sz="1200" b="0">
-                <a:solidFill>
-                  <a:srgbClr val="111111"/>
-                </a:solidFill>
-                <a:latin typeface="Calibri"/>
-              </a:rPr>
-              <a:t>Value sachet</a:t>
-            </a:r>
-          </a:p>
-        </p:txBody>
-      </p:sp>
-      <p:sp>
-        <p:nvSpPr>
-          <p:cNvPr id="41" name="Rectangle 40"/>
-          <p:cNvSpPr/>
-          <p:nvPr/>
-        </p:nvSpPr>
-        <p:spPr>
-          <a:xfrm>
-            <a:off x="3273552" y="4974336"/>
-            <a:ext cx="2788920" cy="676656"/>
-          </a:xfrm>
-          <a:prstGeom prst="rect">
-            <a:avLst/>
-          </a:prstGeom>
-          <a:solidFill>
-            <a:srgbClr val="F3F5F7"/>
-          </a:solidFill>
-          <a:ln w="12700">
-            <a:solidFill>
-              <a:srgbClr val="C8D0D8"/>
-            </a:solidFill>
-          </a:ln>
-        </p:spPr>
-        <p:style>
-          <a:lnRef idx="1">
-            <a:schemeClr val="accent1"/>
-          </a:lnRef>
-          <a:fillRef idx="3">
-            <a:schemeClr val="accent1"/>
-          </a:fillRef>
-          <a:effectRef idx="2">
-            <a:schemeClr val="accent1"/>
-          </a:effectRef>
-          <a:fontRef idx="minor">
-            <a:schemeClr val="lt1"/>
-          </a:fontRef>
-        </p:style>
-        <p:txBody>
-          <a:bodyPr rtlCol="0" anchor="ctr"/>
-          <a:lstStyle/>
-          <a:p>
-            <a:pPr algn="ctr"/>
-          </a:p>
-        </p:txBody>
-      </p:sp>
-      <p:sp>
-        <p:nvSpPr>
-          <p:cNvPr id="42" name="Rectangle 41"/>
-          <p:cNvSpPr/>
-          <p:nvPr/>
-        </p:nvSpPr>
-        <p:spPr>
-          <a:xfrm>
-            <a:off x="3273552" y="4974336"/>
-            <a:ext cx="82296" cy="676656"/>
-          </a:xfrm>
-          <a:prstGeom prst="rect">
-            <a:avLst/>
-          </a:prstGeom>
-          <a:solidFill>
-            <a:srgbClr val="1F5FA8"/>
-          </a:solidFill>
-          <a:ln>
-            <a:noFill/>
-          </a:ln>
-        </p:spPr>
-        <p:style>
-          <a:lnRef idx="1">
-            <a:schemeClr val="accent1"/>
-          </a:lnRef>
-          <a:fillRef idx="3">
-            <a:schemeClr val="accent1"/>
-          </a:fillRef>
-          <a:effectRef idx="2">
-            <a:schemeClr val="accent1"/>
-          </a:effectRef>
-          <a:fontRef idx="minor">
-            <a:schemeClr val="lt1"/>
-          </a:fontRef>
-        </p:style>
-        <p:txBody>
-          <a:bodyPr rtlCol="0" anchor="ctr"/>
-          <a:lstStyle/>
-          <a:p>
-            <a:pPr algn="ctr"/>
-          </a:p>
-        </p:txBody>
-      </p:sp>
-      <p:sp>
-        <p:nvSpPr>
-          <p:cNvPr id="43" name="TextBox 42"/>
-          <p:cNvSpPr txBox="1"/>
-          <p:nvPr/>
-        </p:nvSpPr>
-        <p:spPr>
-          <a:xfrm>
-            <a:off x="3456432" y="5020056"/>
-            <a:ext cx="2487168" cy="182880"/>
-          </a:xfrm>
-          <a:prstGeom prst="rect">
-            <a:avLst/>
-          </a:prstGeom>
-          <a:noFill/>
-        </p:spPr>
-        <p:txBody>
-          <a:bodyPr wrap="square">
-            <a:spAutoFit/>
-          </a:bodyPr>
-          <a:lstStyle/>
-          <a:p>
-            <a:pPr algn="l"/>
-            <a:r>
-              <a:rPr sz="1100" b="1">
-                <a:solidFill>
-                  <a:srgbClr val="3D4A55"/>
-                </a:solidFill>
-                <a:latin typeface="Calibri"/>
-              </a:rPr>
-              <a:t>KELLOGG'S</a:t>
-            </a:r>
-          </a:p>
-        </p:txBody>
-      </p:sp>
-      <p:sp>
-        <p:nvSpPr>
-          <p:cNvPr id="44" name="TextBox 43"/>
-          <p:cNvSpPr txBox="1"/>
-          <p:nvPr/>
-        </p:nvSpPr>
-        <p:spPr>
-          <a:xfrm>
-            <a:off x="3456432" y="5193792"/>
-            <a:ext cx="2487168" cy="237744"/>
-          </a:xfrm>
-          <a:prstGeom prst="rect">
-            <a:avLst/>
-          </a:prstGeom>
-          <a:noFill/>
-        </p:spPr>
-        <p:txBody>
-          <a:bodyPr wrap="square">
-            <a:spAutoFit/>
-          </a:bodyPr>
-          <a:lstStyle/>
-          <a:p>
-            <a:pPr algn="l"/>
-            <a:r>
-              <a:rPr sz="2000" b="1">
-                <a:solidFill>
-                  <a:srgbClr val="122A4A"/>
-                </a:solidFill>
-                <a:latin typeface="Calibri"/>
-              </a:rPr>
-              <a:t>R6.09</a:t>
-            </a:r>
-          </a:p>
-        </p:txBody>
-      </p:sp>
-      <p:sp>
-        <p:nvSpPr>
-          <p:cNvPr id="45" name="TextBox 44"/>
-          <p:cNvSpPr txBox="1"/>
-          <p:nvPr/>
-        </p:nvSpPr>
-        <p:spPr>
-          <a:xfrm>
-            <a:off x="3456432" y="5431536"/>
-            <a:ext cx="2487168" cy="182880"/>
-          </a:xfrm>
-          <a:prstGeom prst="rect">
-            <a:avLst/>
-          </a:prstGeom>
-          <a:noFill/>
-        </p:spPr>
-        <p:txBody>
-          <a:bodyPr wrap="square">
-            <a:spAutoFit/>
-          </a:bodyPr>
-          <a:lstStyle/>
-          <a:p>
-            <a:pPr algn="l"/>
-            <a:r>
-              <a:rPr sz="1200" b="0">
-                <a:solidFill>
-                  <a:srgbClr val="111111"/>
-                </a:solidFill>
-                <a:latin typeface="Calibri"/>
-              </a:rPr>
-              <a:t>Maggi R6.79  ·  Indomie R7.90</a:t>
-            </a:r>
-          </a:p>
-        </p:txBody>
-      </p:sp>
-      <p:sp>
-        <p:nvSpPr>
-          <p:cNvPr id="46" name="Rectangle 45"/>
-          <p:cNvSpPr/>
-          <p:nvPr/>
-        </p:nvSpPr>
-        <p:spPr>
-          <a:xfrm>
-            <a:off x="347472" y="5724144"/>
-            <a:ext cx="2788920" cy="676656"/>
-          </a:xfrm>
-          <a:prstGeom prst="rect">
-            <a:avLst/>
-          </a:prstGeom>
-          <a:solidFill>
-            <a:srgbClr val="F3F5F7"/>
-          </a:solidFill>
-          <a:ln w="12700">
-            <a:solidFill>
-              <a:srgbClr val="C8D0D8"/>
-            </a:solidFill>
-          </a:ln>
-        </p:spPr>
-        <p:style>
-          <a:lnRef idx="1">
-            <a:schemeClr val="accent1"/>
-          </a:lnRef>
-          <a:fillRef idx="3">
-            <a:schemeClr val="accent1"/>
-          </a:fillRef>
-          <a:effectRef idx="2">
-            <a:schemeClr val="accent1"/>
-          </a:effectRef>
-          <a:fontRef idx="minor">
-            <a:schemeClr val="lt1"/>
-          </a:fontRef>
-        </p:style>
-        <p:txBody>
-          <a:bodyPr rtlCol="0" anchor="ctr"/>
-          <a:lstStyle/>
-          <a:p>
-            <a:pPr algn="ctr"/>
-          </a:p>
-        </p:txBody>
-      </p:sp>
-      <p:sp>
-        <p:nvSpPr>
-          <p:cNvPr id="47" name="Rectangle 46"/>
-          <p:cNvSpPr/>
-          <p:nvPr/>
-        </p:nvSpPr>
-        <p:spPr>
-          <a:xfrm>
-            <a:off x="347472" y="5724144"/>
-            <a:ext cx="82296" cy="676656"/>
-          </a:xfrm>
-          <a:prstGeom prst="rect">
-            <a:avLst/>
-          </a:prstGeom>
-          <a:solidFill>
-            <a:srgbClr val="0E7C7B"/>
-          </a:solidFill>
-          <a:ln>
-            <a:noFill/>
-          </a:ln>
-        </p:spPr>
-        <p:style>
-          <a:lnRef idx="1">
-            <a:schemeClr val="accent1"/>
-          </a:lnRef>
-          <a:fillRef idx="3">
-            <a:schemeClr val="accent1"/>
-          </a:fillRef>
-          <a:effectRef idx="2">
-            <a:schemeClr val="accent1"/>
-          </a:effectRef>
-          <a:fontRef idx="minor">
-            <a:schemeClr val="lt1"/>
-          </a:fontRef>
-        </p:style>
-        <p:txBody>
-          <a:bodyPr rtlCol="0" anchor="ctr"/>
-          <a:lstStyle/>
-          <a:p>
-            <a:pPr algn="ctr"/>
-          </a:p>
-        </p:txBody>
-      </p:sp>
-      <p:sp>
-        <p:nvSpPr>
-          <p:cNvPr id="48" name="TextBox 47"/>
-          <p:cNvSpPr txBox="1"/>
-          <p:nvPr/>
-        </p:nvSpPr>
-        <p:spPr>
-          <a:xfrm>
-            <a:off x="530352" y="5769864"/>
-            <a:ext cx="2487168" cy="182880"/>
-          </a:xfrm>
-          <a:prstGeom prst="rect">
-            <a:avLst/>
-          </a:prstGeom>
-          <a:noFill/>
-        </p:spPr>
-        <p:txBody>
-          <a:bodyPr wrap="square">
-            <a:spAutoFit/>
-          </a:bodyPr>
-          <a:lstStyle/>
-          <a:p>
-            <a:pPr algn="l"/>
-            <a:r>
-              <a:rPr sz="1100" b="1">
-                <a:solidFill>
-                  <a:srgbClr val="3D4A55"/>
-                </a:solidFill>
-                <a:latin typeface="Calibri"/>
-              </a:rPr>
-              <a:t>SAMYANG</a:t>
-            </a:r>
-          </a:p>
-        </p:txBody>
-      </p:sp>
-      <p:sp>
-        <p:nvSpPr>
-          <p:cNvPr id="49" name="TextBox 48"/>
-          <p:cNvSpPr txBox="1"/>
-          <p:nvPr/>
-        </p:nvSpPr>
-        <p:spPr>
-          <a:xfrm>
-            <a:off x="530352" y="5943600"/>
-            <a:ext cx="2487168" cy="237744"/>
-          </a:xfrm>
-          <a:prstGeom prst="rect">
-            <a:avLst/>
-          </a:prstGeom>
-          <a:noFill/>
-        </p:spPr>
-        <p:txBody>
-          <a:bodyPr wrap="square">
-            <a:spAutoFit/>
-          </a:bodyPr>
-          <a:lstStyle/>
-          <a:p>
-            <a:pPr algn="l"/>
-            <a:r>
-              <a:rPr sz="2000" b="1">
-                <a:solidFill>
-                  <a:srgbClr val="122A4A"/>
-                </a:solidFill>
-                <a:latin typeface="Calibri"/>
-              </a:rPr>
-              <a:t>R39.24</a:t>
-            </a:r>
-          </a:p>
-        </p:txBody>
-      </p:sp>
-      <p:sp>
-        <p:nvSpPr>
-          <p:cNvPr id="50" name="TextBox 49"/>
-          <p:cNvSpPr txBox="1"/>
-          <p:nvPr/>
-        </p:nvSpPr>
-        <p:spPr>
-          <a:xfrm>
-            <a:off x="530352" y="6181344"/>
-            <a:ext cx="2487168" cy="182880"/>
-          </a:xfrm>
-          <a:prstGeom prst="rect">
-            <a:avLst/>
-          </a:prstGeom>
-          <a:noFill/>
-        </p:spPr>
-        <p:txBody>
-          <a:bodyPr wrap="square">
-            <a:spAutoFit/>
-          </a:bodyPr>
-          <a:lstStyle/>
-          <a:p>
-            <a:pPr algn="l"/>
-            <a:r>
-              <a:rPr sz="1200" b="0">
-                <a:solidFill>
-                  <a:srgbClr val="111111"/>
-                </a:solidFill>
-                <a:latin typeface="Calibri"/>
-              </a:rPr>
-              <a:t>Ramen / cup</a:t>
-            </a:r>
-          </a:p>
-        </p:txBody>
-      </p:sp>
-      <p:sp>
-        <p:nvSpPr>
-          <p:cNvPr id="51" name="Rectangle 50"/>
-          <p:cNvSpPr/>
-          <p:nvPr/>
-        </p:nvSpPr>
-        <p:spPr>
-          <a:xfrm>
-            <a:off x="3273552" y="5724144"/>
-            <a:ext cx="2788920" cy="676656"/>
-          </a:xfrm>
-          <a:prstGeom prst="rect">
-            <a:avLst/>
-          </a:prstGeom>
-          <a:solidFill>
-            <a:srgbClr val="F3F5F7"/>
-          </a:solidFill>
-          <a:ln w="12700">
-            <a:solidFill>
-              <a:srgbClr val="C8D0D8"/>
-            </a:solidFill>
-          </a:ln>
-        </p:spPr>
-        <p:style>
-          <a:lnRef idx="1">
-            <a:schemeClr val="accent1"/>
-          </a:lnRef>
-          <a:fillRef idx="3">
-            <a:schemeClr val="accent1"/>
-          </a:fillRef>
-          <a:effectRef idx="2">
-            <a:schemeClr val="accent1"/>
-          </a:effectRef>
-          <a:fontRef idx="minor">
-            <a:schemeClr val="lt1"/>
-          </a:fontRef>
-        </p:style>
-        <p:txBody>
-          <a:bodyPr rtlCol="0" anchor="ctr"/>
-          <a:lstStyle/>
-          <a:p>
-            <a:pPr algn="ctr"/>
-          </a:p>
-        </p:txBody>
-      </p:sp>
-      <p:sp>
-        <p:nvSpPr>
-          <p:cNvPr id="52" name="Rectangle 51"/>
-          <p:cNvSpPr/>
-          <p:nvPr/>
-        </p:nvSpPr>
-        <p:spPr>
-          <a:xfrm>
-            <a:off x="3273552" y="5724144"/>
-            <a:ext cx="82296" cy="676656"/>
+            <a:off x="6309360" y="1097280"/>
+            <a:ext cx="82296" cy="1417320"/>
           </a:xfrm>
           <a:prstGeom prst="rect">
             <a:avLst/>
@@ -8485,119 +8363,14 @@
       </p:sp>
       <p:sp>
         <p:nvSpPr>
-          <p:cNvPr id="53" name="TextBox 52"/>
+          <p:cNvPr id="17" name="TextBox 16"/>
           <p:cNvSpPr txBox="1"/>
           <p:nvPr/>
         </p:nvSpPr>
         <p:spPr>
           <a:xfrm>
-            <a:off x="3456432" y="5769864"/>
-            <a:ext cx="2487168" cy="182880"/>
-          </a:xfrm>
-          <a:prstGeom prst="rect">
-            <a:avLst/>
-          </a:prstGeom>
-          <a:noFill/>
-        </p:spPr>
-        <p:txBody>
-          <a:bodyPr wrap="square">
-            <a:spAutoFit/>
-          </a:bodyPr>
-          <a:lstStyle/>
-          <a:p>
-            <a:pPr algn="l"/>
-            <a:r>
-              <a:rPr sz="1100" b="1">
-                <a:solidFill>
-                  <a:srgbClr val="3D4A55"/>
-                </a:solidFill>
-                <a:latin typeface="Calibri"/>
-              </a:rPr>
-              <a:t>KNORR</a:t>
-            </a:r>
-          </a:p>
-        </p:txBody>
-      </p:sp>
-      <p:sp>
-        <p:nvSpPr>
-          <p:cNvPr id="54" name="TextBox 53"/>
-          <p:cNvSpPr txBox="1"/>
-          <p:nvPr/>
-        </p:nvSpPr>
-        <p:spPr>
-          <a:xfrm>
-            <a:off x="3456432" y="5943600"/>
-            <a:ext cx="2487168" cy="237744"/>
-          </a:xfrm>
-          <a:prstGeom prst="rect">
-            <a:avLst/>
-          </a:prstGeom>
-          <a:noFill/>
-        </p:spPr>
-        <p:txBody>
-          <a:bodyPr wrap="square">
-            <a:spAutoFit/>
-          </a:bodyPr>
-          <a:lstStyle/>
-          <a:p>
-            <a:pPr algn="l"/>
-            <a:r>
-              <a:rPr sz="2000" b="1">
-                <a:solidFill>
-                  <a:srgbClr val="122A4A"/>
-                </a:solidFill>
-                <a:latin typeface="Calibri"/>
-              </a:rPr>
-              <a:t>R49.11</a:t>
-            </a:r>
-          </a:p>
-        </p:txBody>
-      </p:sp>
-      <p:sp>
-        <p:nvSpPr>
-          <p:cNvPr id="55" name="TextBox 54"/>
-          <p:cNvSpPr txBox="1"/>
-          <p:nvPr/>
-        </p:nvSpPr>
-        <p:spPr>
-          <a:xfrm>
-            <a:off x="3456432" y="6181344"/>
-            <a:ext cx="2487168" cy="182880"/>
-          </a:xfrm>
-          <a:prstGeom prst="rect">
-            <a:avLst/>
-          </a:prstGeom>
-          <a:noFill/>
-        </p:spPr>
-        <p:txBody>
-          <a:bodyPr wrap="square">
-            <a:spAutoFit/>
-          </a:bodyPr>
-          <a:lstStyle/>
-          <a:p>
-            <a:pPr algn="l"/>
-            <a:r>
-              <a:rPr sz="1200" b="0">
-                <a:solidFill>
-                  <a:srgbClr val="111111"/>
-                </a:solidFill>
-                <a:latin typeface="Calibri"/>
-              </a:rPr>
-              <a:t>Pasta Pots  ·  ~8× sachet</a:t>
-            </a:r>
-          </a:p>
-        </p:txBody>
-      </p:sp>
-      <p:sp>
-        <p:nvSpPr>
-          <p:cNvPr id="56" name="TextBox 55"/>
-          <p:cNvSpPr txBox="1"/>
-          <p:nvPr/>
-        </p:nvSpPr>
-        <p:spPr>
-          <a:xfrm>
-            <a:off x="6217920" y="4572000"/>
-            <a:ext cx="5577840" cy="292608"/>
+            <a:off x="6547104" y="1188720"/>
+            <a:ext cx="5120640" cy="292608"/>
           </a:xfrm>
           <a:prstGeom prst="rect">
             <a:avLst/>
@@ -8618,22 +8391,57 @@
                 </a:solidFill>
                 <a:latin typeface="Calibri"/>
               </a:rPr>
-              <a:t>Unilever SKUs — June 2026 only</a:t>
+              <a:t>Pasta Pots are not a sachet</a:t>
+            </a:r>
+          </a:p>
+        </p:txBody>
+      </p:sp>
+      <p:sp>
+        <p:nvSpPr>
+          <p:cNvPr id="18" name="TextBox 17"/>
+          <p:cNvSpPr txBox="1"/>
+          <p:nvPr/>
+        </p:nvSpPr>
+        <p:spPr>
+          <a:xfrm>
+            <a:off x="6547104" y="1499616"/>
+            <a:ext cx="5120640" cy="896112"/>
+          </a:xfrm>
+          <a:prstGeom prst="rect">
+            <a:avLst/>
+          </a:prstGeom>
+          <a:noFill/>
+        </p:spPr>
+        <p:txBody>
+          <a:bodyPr wrap="square">
+            <a:spAutoFit/>
+          </a:bodyPr>
+          <a:lstStyle/>
+          <a:p>
+            <a:pPr algn="l"/>
+            <a:r>
+              <a:rPr sz="1400" b="0">
+                <a:solidFill>
+                  <a:srgbClr val="111111"/>
+                </a:solidFill>
+                <a:latin typeface="Calibri"/>
+              </a:rPr>
+              <a:t>86% of noodles value is R5–8 a pack. Knorr Pasta Pots are R49 a pot / ~R790/kg, 0.56% of Noodles in June (R1.24m). Hold R49; do not promo into the R6 band.</a:t>
             </a:r>
           </a:p>
         </p:txBody>
       </p:sp>
       <p:graphicFrame>
         <p:nvGraphicFramePr>
-          <p:cNvPr id="57" name="Table 56"/>
+          <p:cNvPr id="19" name="Table 18"/>
           <p:cNvGraphicFramePr>
             <a:graphicFrameLocks noGrp="1"/>
           </p:cNvGraphicFramePr>
           <p:nvPr/>
         </p:nvGraphicFramePr>
         <p:xfrm>
-          <a:off x="6217920" y="5047488"/>
-          <a:ext cx="5623560" cy="1417320"/>
+          <a:off x="6309360" y="2670048"/>
+          <a:ext cx="5532120" cy="1965960"/>
         </p:xfrm>
         <a:graphic>
           <a:graphicData uri="http://schemas.openxmlformats.org/drawingml/2006/table">
@@ -8642,12 +8450,12 @@
                 <a:tableStyleId>{5C22544A-7EE6-4342-B048-85BDC9FD1C3A}</a:tableStyleId>
               </a:tblPr>
               <a:tblGrid>
-                <a:gridCol w="2194560"/>
-                <a:gridCol w="1097280"/>
+                <a:gridCol w="2148840"/>
+                <a:gridCol w="1051560"/>
                 <a:gridCol w="1051560"/>
                 <a:gridCol w="1280160"/>
               </a:tblGrid>
-              <a:tr h="354330">
+              <a:tr h="491490">
                 <a:tc>
                   <a:txBody>
                     <a:bodyPr/>
@@ -8741,7 +8549,7 @@
                   </a:tcPr>
                 </a:tc>
               </a:tr>
-              <a:tr h="354330">
+              <a:tr h="491490">
                 <a:tc>
                   <a:txBody>
                     <a:bodyPr/>
@@ -8835,7 +8643,7 @@
                   </a:tcPr>
                 </a:tc>
               </a:tr>
-              <a:tr h="354330">
+              <a:tr h="491490">
                 <a:tc>
                   <a:txBody>
                     <a:bodyPr/>
@@ -8929,7 +8737,7 @@
                   </a:tcPr>
                 </a:tc>
               </a:tr>
-              <a:tr h="354330">
+              <a:tr h="491490">
                 <a:tc>
                   <a:txBody>
                     <a:bodyPr/>
@@ -9027,6 +8835,41 @@
           </a:graphicData>
         </a:graphic>
       </p:graphicFrame>
+      <p:sp>
+        <p:nvSpPr>
+          <p:cNvPr id="20" name="TextBox 19"/>
+          <p:cNvSpPr txBox="1"/>
+          <p:nvPr/>
+        </p:nvSpPr>
+        <p:spPr>
+          <a:xfrm>
+            <a:off x="6309360" y="4773168"/>
+            <a:ext cx="5532120" cy="1554480"/>
+          </a:xfrm>
+          <a:prstGeom prst="rect">
+            <a:avLst/>
+          </a:prstGeom>
+          <a:noFill/>
+        </p:spPr>
+        <p:txBody>
+          <a:bodyPr wrap="square">
+            <a:spAutoFit/>
+          </a:bodyPr>
+          <a:lstStyle/>
+          <a:p>
+            <a:pPr algn="l"/>
+            <a:r>
+              <a:rPr sz="1400" b="0">
+                <a:solidFill>
+                  <a:srgbClr val="111111"/>
+                </a:solidFill>
+                <a:latin typeface="Calibri"/>
+              </a:rPr>
+              <a:t>Not in the file before June. Carbonara is 49% of the line. The three SKUs compete with each other first. Samyang (~R39) is the nearer competitor, not Maggi or Kellogg's.</a:t>
+            </a:r>
+          </a:p>
+        </p:txBody>
+      </p:sp>
     </p:spTree>
   </p:cSld>
   <p:clrMapOvr>
@@ -9035,7 +8878,7 @@
 </p:sld>
 </file>
 
-<file path=ppt/slides/slide4.xml><?xml version="1.0" encoding="utf-8"?>
+<file path=ppt/slides/slide5.xml><?xml version="1.0" encoding="utf-8"?>
 <p:sld xmlns:a="http://schemas.openxmlformats.org/drawingml/2006/main" xmlns:p="http://schemas.openxmlformats.org/presentationml/2006/main" xmlns:r="http://schemas.openxmlformats.org/officeDocument/2006/relationships">
   <p:cSld>
     <p:spTree>
@@ -9384,7 +9227,7 @@
                 </a:solidFill>
                 <a:latin typeface="Calibri"/>
               </a:rPr>
-              <a:t>4 / 5</a:t>
+              <a:t>5 / 6</a:t>
             </a:r>
           </a:p>
         </p:txBody>
@@ -10169,7 +10012,7 @@
 </p:sld>
 </file>
 
-<file path=ppt/slides/slide5.xml><?xml version="1.0" encoding="utf-8"?>
+<file path=ppt/slides/slide6.xml><?xml version="1.0" encoding="utf-8"?>
 <p:sld xmlns:a="http://schemas.openxmlformats.org/drawingml/2006/main" xmlns:p="http://schemas.openxmlformats.org/presentationml/2006/main" xmlns:r="http://schemas.openxmlformats.org/officeDocument/2006/relationships">
   <p:cSld>
     <p:spTree>

</xml_diff>